<commit_message>
feat: complete SME credit readiness vertical slice, five-minute pitch deck, and bilingual scripts
</commit_message>
<xml_diff>
--- a/presentation/FinSight_AI_Pitch_Deck.pptx
+++ b/presentation/FinSight_AI_Pitch_Deck.pptx
@@ -11,8 +11,6 @@
     <p:sldId id="259" r:id="rId10"/>
     <p:sldId id="260" r:id="rId11"/>
     <p:sldId id="261" r:id="rId12"/>
-    <p:sldId id="262" r:id="rId13"/>
-    <p:sldId id="263" r:id="rId14"/>
   </p:sldIdLst>
   <p:sldSz cx="12191695" cy="6858000" type="screen4x3"/>
   <p:notesSz cx="6858000" cy="9144000"/>
@@ -3148,7 +3146,7 @@
         </p:nvSpPr>
         <p:spPr>
           <a:xfrm>
-            <a:off x="914400" y="1645920"/>
+            <a:off x="914400" y="1554480"/>
             <a:ext cx="10332720" cy="3474720"/>
           </a:xfrm>
           <a:prstGeom prst="rect">
@@ -3170,7 +3168,7 @@
               </a:defRPr>
             </a:pPr>
             <a:r>
-              <a:t>AI2B HACKATHON 2026 • COMMERCIAL BANKING VERTICAL SLICE</a:t>
+              <a:t>AI2B HACKATHON 2026 • COMMERCIAL CREDIT &amp; CAPITAL READINESS</a:t>
             </a:r>
           </a:p>
           <a:p>
@@ -3178,7 +3176,7 @@
               <a:spcAft>
                 <a:spcPts val="1000"/>
               </a:spcAft>
-              <a:defRPr sz="5400" b="1">
+              <a:defRPr sz="5600" b="1">
                 <a:solidFill>
                   <a:srgbClr val="FFFFFF"/>
                 </a:solidFill>
@@ -3193,14 +3191,14 @@
               <a:spcAft>
                 <a:spcPts val="2000"/>
               </a:spcAft>
-              <a:defRPr sz="2200">
+              <a:defRPr sz="2400">
                 <a:solidFill>
                   <a:srgbClr val="38BDF8"/>
                 </a:solidFill>
               </a:defRPr>
             </a:pPr>
             <a:r>
-              <a:t>Autonomous Financial Intelligence &amp; Credit Decision Engine</a:t>
+              <a:t>The Autonomous Credit &amp; Capital Readiness Engine for SMEs</a:t>
             </a:r>
           </a:p>
           <a:p>
@@ -3212,11 +3210,11 @@
               </a:defRPr>
             </a:pPr>
             <a:r>
-              <a:t>Turning fragmented balance sheets, public economic data, and narrative ESG claims</a:t>
+              <a:t>Empowering European SMEs to unlock optimal bank financing:</a:t>
             </a:r>
             <a:br/>
             <a:r>
-              <a:t>into explainable, deterministic credit intelligence in under 10 seconds.</a:t>
+              <a:t>Turning historical balance sheets, central bank benchmarks, and ESG audits into a certified credit dossier in 14 seconds.</a:t>
             </a:r>
           </a:p>
         </p:txBody>
@@ -3296,7 +3294,7 @@
               </a:defRPr>
             </a:pPr>
             <a:r>
-              <a:t>TEAM: Loop Troops   |   CASE: EcoTex Milano (€750k Green Loan)   |   CORE PRINCIPLE: The LLM is NOT the calculator</a:t>
+              <a:t>TEAM: Loop Troops  |  PROVING CASE: EcoTex Milano (€750k Green Loan)  |  TECH: DuckDB + Python 3.11 + Streamlit</a:t>
             </a:r>
           </a:p>
         </p:txBody>
@@ -3372,8 +3370,44 @@
         </p:nvSpPr>
         <p:spPr>
           <a:xfrm>
-            <a:off x="731520" y="457200"/>
-            <a:ext cx="10698480" cy="365760"/>
+            <a:off x="731520" y="411480"/>
+            <a:ext cx="10698480" cy="320040"/>
+          </a:xfrm>
+          <a:prstGeom prst="rect">
+            <a:avLst/>
+          </a:prstGeom>
+          <a:noFill/>
+        </p:spPr>
+        <p:txBody>
+          <a:bodyPr wrap="none">
+            <a:spAutoFit/>
+          </a:bodyPr>
+          <a:lstStyle/>
+          <a:p>
+            <a:pPr>
+              <a:defRPr sz="1100" b="1">
+                <a:solidFill>
+                  <a:srgbClr val="38BDF8"/>
+                </a:solidFill>
+                <a:latin typeface="Arial"/>
+              </a:defRPr>
+            </a:pPr>
+            <a:r>
+              <a:t>THE MARKET FRICTION</a:t>
+            </a:r>
+          </a:p>
+        </p:txBody>
+      </p:sp>
+      <p:sp>
+        <p:nvSpPr>
+          <p:cNvPr id="4" name="TextBox 3"/>
+          <p:cNvSpPr txBox="1"/>
+          <p:nvPr/>
+        </p:nvSpPr>
+        <p:spPr>
+          <a:xfrm>
+            <a:off x="731520" y="777240"/>
+            <a:ext cx="10698480" cy="914400"/>
           </a:xfrm>
           <a:prstGeom prst="rect">
             <a:avLst/>
@@ -3387,64 +3421,28 @@
           <a:lstStyle/>
           <a:p>
             <a:pPr>
-              <a:defRPr sz="1000" b="1">
-                <a:solidFill>
-                  <a:srgbClr val="38BDF8"/>
+              <a:defRPr sz="2800" b="1">
+                <a:solidFill>
+                  <a:srgbClr val="FFFFFF"/>
                 </a:solidFill>
                 <a:latin typeface="Arial"/>
               </a:defRPr>
             </a:pPr>
             <a:r>
-              <a:t>MARKET FRICTION &amp; OPPORTUNITY</a:t>
-            </a:r>
-          </a:p>
-        </p:txBody>
-      </p:sp>
-      <p:sp>
-        <p:nvSpPr>
-          <p:cNvPr id="4" name="TextBox 3"/>
-          <p:cNvSpPr txBox="1"/>
-          <p:nvPr/>
-        </p:nvSpPr>
-        <p:spPr>
-          <a:xfrm>
-            <a:off x="731520" y="777240"/>
-            <a:ext cx="10698480" cy="731520"/>
-          </a:xfrm>
-          <a:prstGeom prst="rect">
-            <a:avLst/>
-          </a:prstGeom>
-          <a:noFill/>
-        </p:spPr>
-        <p:txBody>
-          <a:bodyPr wrap="square">
-            <a:spAutoFit/>
-          </a:bodyPr>
-          <a:lstStyle/>
-          <a:p>
-            <a:pPr>
-              <a:defRPr sz="2400" b="1">
-                <a:solidFill>
-                  <a:srgbClr val="FFFFFF"/>
+              <a:t>Why 40% of Sound SMEs Face Rejection or Rate Spikes</a:t>
+            </a:r>
+          </a:p>
+          <a:p>
+            <a:pPr>
+              <a:defRPr sz="1400">
+                <a:solidFill>
+                  <a:srgbClr val="94A3B8"/>
                 </a:solidFill>
                 <a:latin typeface="Arial"/>
               </a:defRPr>
             </a:pPr>
             <a:r>
-              <a:t>The €400B Blindspot in SME Commercial Lending</a:t>
-            </a:r>
-          </a:p>
-          <a:p>
-            <a:pPr>
-              <a:defRPr sz="1300">
-                <a:solidFill>
-                  <a:srgbClr val="94A3B8"/>
-                </a:solidFill>
-                <a:latin typeface="Arial"/>
-              </a:defRPr>
-            </a:pPr>
-            <a:r>
-              <a:t>Relationship Managers spend 3 weeks stitching fragmented evidence while loans stall.</a:t>
+              <a:t>SMEs apply to banks blindfolded, triggering delays, covenant breaches, and mispriced loans.</a:t>
             </a:r>
           </a:p>
         </p:txBody>
@@ -3503,7 +3501,7 @@
         <p:spPr>
           <a:xfrm>
             <a:off x="914400" y="2148840"/>
-            <a:ext cx="3017520" cy="457200"/>
+            <a:ext cx="3017520" cy="411480"/>
           </a:xfrm>
           <a:prstGeom prst="rect">
             <a:avLst/>
@@ -3525,7 +3523,7 @@
               </a:defRPr>
             </a:pPr>
             <a:r>
-              <a:t>SILO 1: FINANCIAL STATEMENTS</a:t>
+              <a:t>THE INFORMATION ASYMMETRY</a:t>
             </a:r>
           </a:p>
         </p:txBody>
@@ -3538,8 +3536,8 @@
         </p:nvSpPr>
         <p:spPr>
           <a:xfrm>
-            <a:off x="914400" y="2651760"/>
-            <a:ext cx="3017520" cy="3200400"/>
+            <a:off x="914400" y="2606040"/>
+            <a:ext cx="3017520" cy="3383280"/>
           </a:xfrm>
           <a:prstGeom prst="rect">
             <a:avLst/>
@@ -3554,22 +3552,22 @@
           <a:p>
             <a:pPr>
               <a:spcAft>
-                <a:spcPts val="1200"/>
+                <a:spcPts val="1000"/>
               </a:spcAft>
-              <a:defRPr sz="1400" b="1">
+              <a:defRPr sz="1500" b="1">
                 <a:solidFill>
                   <a:srgbClr val="FFFFFF"/>
                 </a:solidFill>
               </a:defRPr>
             </a:pPr>
             <a:r>
-              <a:t>Proprietary ERP &amp; Balance Sheets</a:t>
+              <a:t>Borrowing in the Dark</a:t>
             </a:r>
           </a:p>
           <a:p>
             <a:pPr>
               <a:spcAft>
-                <a:spcPts val="600"/>
+                <a:spcPts val="500"/>
               </a:spcAft>
               <a:defRPr sz="1200">
                 <a:solidFill>
@@ -3578,13 +3576,13 @@
               </a:defRPr>
             </a:pPr>
             <a:r>
-              <a:t>• Historical, backwards-looking data</a:t>
+              <a:t>• SMEs have no visibility into how credit algorithms evaluate their risk.</a:t>
             </a:r>
           </a:p>
           <a:p>
             <a:pPr>
               <a:spcAft>
-                <a:spcPts val="600"/>
+                <a:spcPts val="500"/>
               </a:spcAft>
               <a:defRPr sz="1200">
                 <a:solidFill>
@@ -3593,13 +3591,13 @@
               </a:defRPr>
             </a:pPr>
             <a:r>
-              <a:t>• Trapped in unstructured PDF reports</a:t>
+              <a:t>• They apply without benchmarking against regional default data.</a:t>
             </a:r>
           </a:p>
           <a:p>
             <a:pPr>
               <a:spcAft>
-                <a:spcPts val="600"/>
+                <a:spcPts val="500"/>
               </a:spcAft>
               <a:defRPr sz="1200">
                 <a:solidFill>
@@ -3608,13 +3606,13 @@
               </a:defRPr>
             </a:pPr>
             <a:r>
-              <a:t>• Manual ratio calculations prone to human latency</a:t>
+              <a:t>• No tool to simulate debt limits before formal application.</a:t>
             </a:r>
           </a:p>
           <a:p>
             <a:pPr>
               <a:spcAft>
-                <a:spcPts val="600"/>
+                <a:spcPts val="500"/>
               </a:spcAft>
               <a:defRPr sz="1200">
                 <a:solidFill>
@@ -3623,7 +3621,7 @@
               </a:defRPr>
             </a:pPr>
             <a:r>
-              <a:t>• Takes 4 to 8 hours per dossier</a:t>
+              <a:t>• Leads to preventable rejections and higher interest margins.</a:t>
             </a:r>
           </a:p>
         </p:txBody>
@@ -3682,7 +3680,7 @@
         <p:spPr>
           <a:xfrm>
             <a:off x="4572000" y="2148840"/>
-            <a:ext cx="3017520" cy="457200"/>
+            <a:ext cx="3017520" cy="411480"/>
           </a:xfrm>
           <a:prstGeom prst="rect">
             <a:avLst/>
@@ -3704,7 +3702,7 @@
               </a:defRPr>
             </a:pPr>
             <a:r>
-              <a:t>SILO 2: MACRO &amp; REGIONAL CONTEXT</a:t>
+              <a:t>THE LATENCY PENALTY</a:t>
             </a:r>
           </a:p>
         </p:txBody>
@@ -3717,8 +3715,8 @@
         </p:nvSpPr>
         <p:spPr>
           <a:xfrm>
-            <a:off x="4572000" y="2651760"/>
-            <a:ext cx="3017520" cy="3200400"/>
+            <a:off x="4572000" y="2606040"/>
+            <a:ext cx="3017520" cy="3383280"/>
           </a:xfrm>
           <a:prstGeom prst="rect">
             <a:avLst/>
@@ -3733,22 +3731,22 @@
           <a:p>
             <a:pPr>
               <a:spcAft>
-                <a:spcPts val="1200"/>
+                <a:spcPts val="1000"/>
               </a:spcAft>
-              <a:defRPr sz="1400" b="1">
+              <a:defRPr sz="1500" b="1">
                 <a:solidFill>
                   <a:srgbClr val="FFFFFF"/>
                 </a:solidFill>
               </a:defRPr>
             </a:pPr>
             <a:r>
-              <a:t>Public Benchmarks &amp; Bank of Italy</a:t>
+              <a:t>The 3-Week Bureaucratic Black Hole</a:t>
             </a:r>
           </a:p>
           <a:p>
             <a:pPr>
               <a:spcAft>
-                <a:spcPts val="600"/>
+                <a:spcPts val="500"/>
               </a:spcAft>
               <a:defRPr sz="1200">
                 <a:solidFill>
@@ -3757,13 +3755,13 @@
               </a:defRPr>
             </a:pPr>
             <a:r>
-              <a:t>• Banca d'Italia credit default series rarely integrated</a:t>
+              <a:t>• Assembling financial reports and ESG proof takes weeks of manual work.</a:t>
             </a:r>
           </a:p>
           <a:p>
             <a:pPr>
               <a:spcAft>
-                <a:spcPts val="600"/>
+                <a:spcPts val="500"/>
               </a:spcAft>
               <a:defRPr sz="1200">
                 <a:solidFill>
@@ -3772,13 +3770,13 @@
               </a:defRPr>
             </a:pPr>
             <a:r>
-              <a:t>• Regional open data (Lombardia) ignored</a:t>
+              <a:t>• Bank underwriters manually re-key accounting data into spreadsheets.</a:t>
             </a:r>
           </a:p>
           <a:p>
             <a:pPr>
               <a:spcAft>
-                <a:spcPts val="600"/>
+                <a:spcPts val="500"/>
               </a:spcAft>
               <a:defRPr sz="1200">
                 <a:solidFill>
@@ -3787,13 +3785,13 @@
               </a:defRPr>
             </a:pPr>
             <a:r>
-              <a:t>• Underwriters miss local sector trends</a:t>
+              <a:t>• Capex machinery investments stall, delaying business growth.</a:t>
             </a:r>
           </a:p>
           <a:p>
             <a:pPr>
               <a:spcAft>
-                <a:spcPts val="600"/>
+                <a:spcPts val="500"/>
               </a:spcAft>
               <a:defRPr sz="1200">
                 <a:solidFill>
@@ -3802,7 +3800,7 @@
               </a:defRPr>
             </a:pPr>
             <a:r>
-              <a:t>• Mispricing of regional risk spreads</a:t>
+              <a:t>• Competitors seize market opportunities while loans sit in underwriting.</a:t>
             </a:r>
           </a:p>
         </p:txBody>
@@ -3861,7 +3859,7 @@
         <p:spPr>
           <a:xfrm>
             <a:off x="8229600" y="2148840"/>
-            <a:ext cx="3017520" cy="457200"/>
+            <a:ext cx="3017520" cy="411480"/>
           </a:xfrm>
           <a:prstGeom prst="rect">
             <a:avLst/>
@@ -3883,7 +3881,7 @@
               </a:defRPr>
             </a:pPr>
             <a:r>
-              <a:t>SILO 3: SUSTAINABILITY &amp; ESG</a:t>
+              <a:t>THE ESG MONETIZATION GAP</a:t>
             </a:r>
           </a:p>
         </p:txBody>
@@ -3896,8 +3894,8 @@
         </p:nvSpPr>
         <p:spPr>
           <a:xfrm>
-            <a:off x="8229600" y="2651760"/>
-            <a:ext cx="3017520" cy="3200400"/>
+            <a:off x="8229600" y="2606040"/>
+            <a:ext cx="3017520" cy="3383280"/>
           </a:xfrm>
           <a:prstGeom prst="rect">
             <a:avLst/>
@@ -3912,22 +3910,22 @@
           <a:p>
             <a:pPr>
               <a:spcAft>
-                <a:spcPts val="1200"/>
+                <a:spcPts val="1000"/>
               </a:spcAft>
-              <a:defRPr sz="1400" b="1">
+              <a:defRPr sz="1500" b="1">
                 <a:solidFill>
                   <a:srgbClr val="FFFFFF"/>
                 </a:solidFill>
               </a:defRPr>
             </a:pPr>
             <a:r>
-              <a:t>Narrative Audits &amp; Green Taxonomy</a:t>
+              <a:t>Unrewarded Sustainability</a:t>
             </a:r>
           </a:p>
           <a:p>
             <a:pPr>
               <a:spcAft>
-                <a:spcPts val="600"/>
+                <a:spcPts val="500"/>
               </a:spcAft>
               <a:defRPr sz="1200">
                 <a:solidFill>
@@ -3936,13 +3934,13 @@
               </a:defRPr>
             </a:pPr>
             <a:r>
-              <a:t>• Unverified sustainability claims</a:t>
+              <a:t>• SMEs invest in decarbonization and energy efficiency without proof.</a:t>
             </a:r>
           </a:p>
           <a:p>
             <a:pPr>
               <a:spcAft>
-                <a:spcPts val="600"/>
+                <a:spcPts val="500"/>
               </a:spcAft>
               <a:defRPr sz="1200">
                 <a:solidFill>
@@ -3951,13 +3949,13 @@
               </a:defRPr>
             </a:pPr>
             <a:r>
-              <a:t>• Compliance checklists create cognitive fatigue</a:t>
+              <a:t>• Banks fail to recognize green capex due to lack of verifiable data.</a:t>
             </a:r>
           </a:p>
           <a:p>
             <a:pPr>
               <a:spcAft>
-                <a:spcPts val="600"/>
+                <a:spcPts val="500"/>
               </a:spcAft>
               <a:defRPr sz="1200">
                 <a:solidFill>
@@ -3966,13 +3964,13 @@
               </a:defRPr>
             </a:pPr>
             <a:r>
-              <a:t>• No quantitative link between ESG and default risk</a:t>
+              <a:t>• Companies miss subsidized loan rates and regional transition grants.</a:t>
             </a:r>
           </a:p>
           <a:p>
             <a:pPr>
               <a:spcAft>
-                <a:spcPts val="600"/>
+                <a:spcPts val="500"/>
               </a:spcAft>
               <a:defRPr sz="1200">
                 <a:solidFill>
@@ -3981,7 +3979,7 @@
               </a:defRPr>
             </a:pPr>
             <a:r>
-              <a:t>• €400B green loan backlog across the EU</a:t>
+              <a:t>• Tens of thousands in interest savings left on the table annually.</a:t>
             </a:r>
           </a:p>
         </p:txBody>
@@ -4057,8 +4055,44 @@
         </p:nvSpPr>
         <p:spPr>
           <a:xfrm>
-            <a:off x="731520" y="457200"/>
-            <a:ext cx="10698480" cy="365760"/>
+            <a:off x="731520" y="411480"/>
+            <a:ext cx="10698480" cy="320040"/>
+          </a:xfrm>
+          <a:prstGeom prst="rect">
+            <a:avLst/>
+          </a:prstGeom>
+          <a:noFill/>
+        </p:spPr>
+        <p:txBody>
+          <a:bodyPr wrap="none">
+            <a:spAutoFit/>
+          </a:bodyPr>
+          <a:lstStyle/>
+          <a:p>
+            <a:pPr>
+              <a:defRPr sz="1100" b="1">
+                <a:solidFill>
+                  <a:srgbClr val="38BDF8"/>
+                </a:solidFill>
+                <a:latin typeface="Arial"/>
+              </a:defRPr>
+            </a:pPr>
+            <a:r>
+              <a:t>PROPRIETARY MECHANISM &amp; TECH STACK</a:t>
+            </a:r>
+          </a:p>
+        </p:txBody>
+      </p:sp>
+      <p:sp>
+        <p:nvSpPr>
+          <p:cNvPr id="4" name="TextBox 3"/>
+          <p:cNvSpPr txBox="1"/>
+          <p:nvPr/>
+        </p:nvSpPr>
+        <p:spPr>
+          <a:xfrm>
+            <a:off x="731520" y="777240"/>
+            <a:ext cx="10698480" cy="914400"/>
           </a:xfrm>
           <a:prstGeom prst="rect">
             <a:avLst/>
@@ -4072,64 +4106,28 @@
           <a:lstStyle/>
           <a:p>
             <a:pPr>
-              <a:defRPr sz="1000" b="1">
-                <a:solidFill>
-                  <a:srgbClr val="38BDF8"/>
+              <a:defRPr sz="2800" b="1">
+                <a:solidFill>
+                  <a:srgbClr val="FFFFFF"/>
                 </a:solidFill>
                 <a:latin typeface="Arial"/>
               </a:defRPr>
             </a:pPr>
             <a:r>
-              <a:t>PRODUCT POSITIONING</a:t>
-            </a:r>
-          </a:p>
-        </p:txBody>
-      </p:sp>
-      <p:sp>
-        <p:nvSpPr>
-          <p:cNvPr id="4" name="TextBox 3"/>
-          <p:cNvSpPr txBox="1"/>
-          <p:nvPr/>
-        </p:nvSpPr>
-        <p:spPr>
-          <a:xfrm>
-            <a:off x="731520" y="777240"/>
-            <a:ext cx="10698480" cy="731520"/>
-          </a:xfrm>
-          <a:prstGeom prst="rect">
-            <a:avLst/>
-          </a:prstGeom>
-          <a:noFill/>
-        </p:spPr>
-        <p:txBody>
-          <a:bodyPr wrap="square">
-            <a:spAutoFit/>
-          </a:bodyPr>
-          <a:lstStyle/>
-          <a:p>
-            <a:pPr>
-              <a:defRPr sz="2400" b="1">
-                <a:solidFill>
-                  <a:srgbClr val="FFFFFF"/>
+              <a:t>The 4-Stage Architecture: In-Memory, Deterministic, Auditable</a:t>
+            </a:r>
+          </a:p>
+          <a:p>
+            <a:pPr>
+              <a:defRPr sz="1400">
+                <a:solidFill>
+                  <a:srgbClr val="94A3B8"/>
                 </a:solidFill>
                 <a:latin typeface="Arial"/>
               </a:defRPr>
             </a:pPr>
             <a:r>
-              <a:t>FinSight AI: The Grounded Decision Engine</a:t>
-            </a:r>
-          </a:p>
-          <a:p>
-            <a:pPr>
-              <a:defRPr sz="1300">
-                <a:solidFill>
-                  <a:srgbClr val="94A3B8"/>
-                </a:solidFill>
-                <a:latin typeface="Arial"/>
-              </a:defRPr>
-            </a:pPr>
-            <a:r>
-              <a:t>An AI-powered co-pilot that evaluates credit, tests capital boundaries, and proves every claim.</a:t>
+              <a:t>Zero mathematical hallucination: combining high-speed analytics with evidence-based AI synthesis.</a:t>
             </a:r>
           </a:p>
         </p:txBody>
@@ -4143,7 +4141,7 @@
         <p:spPr>
           <a:xfrm>
             <a:off x="731520" y="2011680"/>
-            <a:ext cx="3383280" cy="4114800"/>
+            <a:ext cx="2560320" cy="4114800"/>
           </a:xfrm>
           <a:prstGeom prst="roundRect">
             <a:avLst/>
@@ -4188,7 +4186,7 @@
         <p:spPr>
           <a:xfrm>
             <a:off x="914400" y="2148840"/>
-            <a:ext cx="3017520" cy="457200"/>
+            <a:ext cx="2194560" cy="411480"/>
           </a:xfrm>
           <a:prstGeom prst="rect">
             <a:avLst/>
@@ -4210,7 +4208,7 @@
               </a:defRPr>
             </a:pPr>
             <a:r>
-              <a:t>01 / MULTI-SOURCE INGESTION</a:t>
+              <a:t>01 / IN-MEMORY CORE</a:t>
             </a:r>
           </a:p>
         </p:txBody>
@@ -4223,8 +4221,8 @@
         </p:nvSpPr>
         <p:spPr>
           <a:xfrm>
-            <a:off x="960120" y="2651760"/>
-            <a:ext cx="2926080" cy="3200400"/>
+            <a:off x="868680" y="2606040"/>
+            <a:ext cx="2286000" cy="3383280"/>
           </a:xfrm>
           <a:prstGeom prst="rect">
             <a:avLst/>
@@ -4239,31 +4237,61 @@
           <a:p>
             <a:pPr>
               <a:spcAft>
-                <a:spcPts val="1400"/>
+                <a:spcPts val="1000"/>
               </a:spcAft>
-              <a:defRPr sz="1600" b="1">
+              <a:defRPr sz="1400" b="1">
                 <a:solidFill>
                   <a:srgbClr val="FFFFFF"/>
                 </a:solidFill>
               </a:defRPr>
             </a:pPr>
             <a:r>
-              <a:t>Unified Data Fabric</a:t>
-            </a:r>
-          </a:p>
-          <a:p>
-            <a:pPr>
-              <a:lnSpc>
-                <a:spcPct val="130000"/>
-              </a:lnSpc>
-              <a:defRPr sz="1300">
+              <a:t>DuckDB 1.0 (OLAP)</a:t>
+            </a:r>
+          </a:p>
+          <a:p>
+            <a:pPr>
+              <a:spcAft>
+                <a:spcPts val="500"/>
+              </a:spcAft>
+              <a:defRPr sz="1150">
                 <a:solidFill>
                   <a:srgbClr val="94A3B8"/>
                 </a:solidFill>
               </a:defRPr>
             </a:pPr>
             <a:r>
-              <a:t>Ingests company balance sheets into DuckDB, queries live Banca d'Italia credit benchmarks, and syncs Open Data Lombardia sector output.</a:t>
+              <a:t>• High-performance columnar SQL engine.</a:t>
+            </a:r>
+          </a:p>
+          <a:p>
+            <a:pPr>
+              <a:spcAft>
+                <a:spcPts val="500"/>
+              </a:spcAft>
+              <a:defRPr sz="1150">
+                <a:solidFill>
+                  <a:srgbClr val="94A3B8"/>
+                </a:solidFill>
+              </a:defRPr>
+            </a:pPr>
+            <a:r>
+              <a:t>• Sub-millisecond parsing of company balance sheets.</a:t>
+            </a:r>
+          </a:p>
+          <a:p>
+            <a:pPr>
+              <a:spcAft>
+                <a:spcPts val="500"/>
+              </a:spcAft>
+              <a:defRPr sz="1150">
+                <a:solidFill>
+                  <a:srgbClr val="94A3B8"/>
+                </a:solidFill>
+              </a:defRPr>
+            </a:pPr>
+            <a:r>
+              <a:t>• Total data sovereignty: financial records remain strictly within local process memory with zero cloud leakage.</a:t>
             </a:r>
           </a:p>
         </p:txBody>
@@ -4276,8 +4304,8 @@
         </p:nvSpPr>
         <p:spPr>
           <a:xfrm>
-            <a:off x="4389120" y="2011680"/>
-            <a:ext cx="3383280" cy="4114800"/>
+            <a:off x="3474720" y="2011680"/>
+            <a:ext cx="2560320" cy="4114800"/>
           </a:xfrm>
           <a:prstGeom prst="roundRect">
             <a:avLst/>
@@ -4321,8 +4349,8 @@
         </p:nvSpPr>
         <p:spPr>
           <a:xfrm>
-            <a:off x="4572000" y="2148840"/>
-            <a:ext cx="3017520" cy="457200"/>
+            <a:off x="3657600" y="2148840"/>
+            <a:ext cx="2194560" cy="411480"/>
           </a:xfrm>
           <a:prstGeom prst="rect">
             <a:avLst/>
@@ -4344,7 +4372,7 @@
               </a:defRPr>
             </a:pPr>
             <a:r>
-              <a:t>02 / GROUNDED EXPLAINABILITY</a:t>
+              <a:t>02 / PUBLIC DATA FUSION</a:t>
             </a:r>
           </a:p>
         </p:txBody>
@@ -4357,8 +4385,8 @@
         </p:nvSpPr>
         <p:spPr>
           <a:xfrm>
-            <a:off x="4617720" y="2651760"/>
-            <a:ext cx="2926080" cy="3200400"/>
+            <a:off x="3611880" y="2606040"/>
+            <a:ext cx="2286000" cy="3383280"/>
           </a:xfrm>
           <a:prstGeom prst="rect">
             <a:avLst/>
@@ -4373,31 +4401,61 @@
           <a:p>
             <a:pPr>
               <a:spcAft>
-                <a:spcPts val="1400"/>
+                <a:spcPts val="1000"/>
               </a:spcAft>
-              <a:defRPr sz="1600" b="1">
+              <a:defRPr sz="1400" b="1">
                 <a:solidFill>
                   <a:srgbClr val="FFFFFF"/>
                 </a:solidFill>
               </a:defRPr>
             </a:pPr>
             <a:r>
-              <a:t>Zero Black-Box Guessing</a:t>
-            </a:r>
-          </a:p>
-          <a:p>
-            <a:pPr>
-              <a:lnSpc>
-                <a:spcPct val="130000"/>
-              </a:lnSpc>
-              <a:defRPr sz="1300">
+              <a:t>Banca d'Italia &amp; OpenData</a:t>
+            </a:r>
+          </a:p>
+          <a:p>
+            <a:pPr>
+              <a:spcAft>
+                <a:spcPts val="500"/>
+              </a:spcAft>
+              <a:defRPr sz="1150">
                 <a:solidFill>
                   <a:srgbClr val="94A3B8"/>
                 </a:solidFill>
               </a:defRPr>
             </a:pPr>
             <a:r>
-              <a:t>Every recommendation is backed by a verified audit trail separating verified FACT, deterministic CALCULATION, and synthesized REASONING.</a:t>
+              <a:t>• Real-time integration of central bank provincial credit default rates (Milan NPL: 1.82%).</a:t>
+            </a:r>
+          </a:p>
+          <a:p>
+            <a:pPr>
+              <a:spcAft>
+                <a:spcPts val="500"/>
+              </a:spcAft>
+              <a:defRPr sz="1150">
+                <a:solidFill>
+                  <a:srgbClr val="94A3B8"/>
+                </a:solidFill>
+              </a:defRPr>
+            </a:pPr>
+            <a:r>
+              <a:t>• Dynamic sync with Open Data Lombardia sector growth (+4.1% YoY).</a:t>
+            </a:r>
+          </a:p>
+          <a:p>
+            <a:pPr>
+              <a:spcAft>
+                <a:spcPts val="500"/>
+              </a:spcAft>
+              <a:defRPr sz="1150">
+                <a:solidFill>
+                  <a:srgbClr val="94A3B8"/>
+                </a:solidFill>
+              </a:defRPr>
+            </a:pPr>
+            <a:r>
+              <a:t>• Transforms local context into interest rate bargaining power.</a:t>
             </a:r>
           </a:p>
         </p:txBody>
@@ -4410,8 +4468,8 @@
         </p:nvSpPr>
         <p:spPr>
           <a:xfrm>
-            <a:off x="8046720" y="2011680"/>
-            <a:ext cx="3383280" cy="4114800"/>
+            <a:off x="6217920" y="2011680"/>
+            <a:ext cx="2560320" cy="4114800"/>
           </a:xfrm>
           <a:prstGeom prst="roundRect">
             <a:avLst/>
@@ -4455,8 +4513,8 @@
         </p:nvSpPr>
         <p:spPr>
           <a:xfrm>
-            <a:off x="8229600" y="2148840"/>
-            <a:ext cx="3017520" cy="457200"/>
+            <a:off x="6400800" y="2148840"/>
+            <a:ext cx="2194560" cy="411480"/>
           </a:xfrm>
           <a:prstGeom prst="rect">
             <a:avLst/>
@@ -4478,7 +4536,7 @@
               </a:defRPr>
             </a:pPr>
             <a:r>
-              <a:t>03 / INSTANT SCENARIO STRESS</a:t>
+              <a:t>03 / DETERMINISTIC POLICY</a:t>
             </a:r>
           </a:p>
         </p:txBody>
@@ -4491,8 +4549,8 @@
         </p:nvSpPr>
         <p:spPr>
           <a:xfrm>
-            <a:off x="8275320" y="2651760"/>
-            <a:ext cx="2926080" cy="3200400"/>
+            <a:off x="6355080" y="2606040"/>
+            <a:ext cx="2286000" cy="3383280"/>
           </a:xfrm>
           <a:prstGeom prst="rect">
             <a:avLst/>
@@ -4507,31 +4565,225 @@
           <a:p>
             <a:pPr>
               <a:spcAft>
-                <a:spcPts val="1400"/>
+                <a:spcPts val="1000"/>
               </a:spcAft>
-              <a:defRPr sz="1600" b="1">
+              <a:defRPr sz="1400" b="1">
                 <a:solidFill>
                   <a:srgbClr val="FFFFFF"/>
                 </a:solidFill>
               </a:defRPr>
             </a:pPr>
             <a:r>
-              <a:t>Capital Tipping Points</a:t>
-            </a:r>
-          </a:p>
-          <a:p>
-            <a:pPr>
-              <a:lnSpc>
-                <a:spcPct val="130000"/>
-              </a:lnSpc>
-              <a:defRPr sz="1300">
+              <a:t>Python 3.11 &amp; Pydantic</a:t>
+            </a:r>
+          </a:p>
+          <a:p>
+            <a:pPr>
+              <a:spcAft>
+                <a:spcPts val="500"/>
+              </a:spcAft>
+              <a:defRPr sz="1150">
                 <a:solidFill>
                   <a:srgbClr val="94A3B8"/>
                 </a:solidFill>
               </a:defRPr>
             </a:pPr>
             <a:r>
-              <a:t>Interactive what-if sensitivity: instantly recalculates DSCR, leverage, and decision thresholds when facility sizing changes.</a:t>
+              <a:t>• Mathematical computation of DSCR (1.68x), Net Debt/EBITDA, and Quick Ratios.</a:t>
+            </a:r>
+          </a:p>
+          <a:p>
+            <a:pPr>
+              <a:spcAft>
+                <a:spcPts val="500"/>
+              </a:spcAft>
+              <a:defRPr sz="1150">
+                <a:solidFill>
+                  <a:srgbClr val="94A3B8"/>
+                </a:solidFill>
+              </a:defRPr>
+            </a:pPr>
+            <a:r>
+              <a:t>• Bank-grade credit scoring rules executed via hard-coded formulas.</a:t>
+            </a:r>
+          </a:p>
+          <a:p>
+            <a:pPr>
+              <a:spcAft>
+                <a:spcPts val="500"/>
+              </a:spcAft>
+              <a:defRPr sz="1150">
+                <a:solidFill>
+                  <a:srgbClr val="94A3B8"/>
+                </a:solidFill>
+              </a:defRPr>
+            </a:pPr>
+            <a:r>
+              <a:t>• Golden Rule: The LLM is NEVER the financial calculator.</a:t>
+            </a:r>
+          </a:p>
+        </p:txBody>
+      </p:sp>
+      <p:sp>
+        <p:nvSpPr>
+          <p:cNvPr id="14" name="Rounded Rectangle 13"/>
+          <p:cNvSpPr/>
+          <p:nvPr/>
+        </p:nvSpPr>
+        <p:spPr>
+          <a:xfrm>
+            <a:off x="8961120" y="2011680"/>
+            <a:ext cx="2560320" cy="4114800"/>
+          </a:xfrm>
+          <a:prstGeom prst="roundRect">
+            <a:avLst/>
+          </a:prstGeom>
+          <a:solidFill>
+            <a:srgbClr val="111827"/>
+          </a:solidFill>
+          <a:ln w="19050">
+            <a:solidFill>
+              <a:srgbClr val="2563EB"/>
+            </a:solidFill>
+          </a:ln>
+        </p:spPr>
+        <p:style>
+          <a:lnRef idx="1">
+            <a:schemeClr val="accent1"/>
+          </a:lnRef>
+          <a:fillRef idx="3">
+            <a:schemeClr val="accent1"/>
+          </a:fillRef>
+          <a:effectRef idx="2">
+            <a:schemeClr val="accent1"/>
+          </a:effectRef>
+          <a:fontRef idx="minor">
+            <a:schemeClr val="lt1"/>
+          </a:fontRef>
+        </p:style>
+        <p:txBody>
+          <a:bodyPr rtlCol="0" anchor="ctr"/>
+          <a:lstStyle/>
+          <a:p>
+            <a:pPr algn="ctr"/>
+          </a:p>
+        </p:txBody>
+      </p:sp>
+      <p:sp>
+        <p:nvSpPr>
+          <p:cNvPr id="15" name="TextBox 14"/>
+          <p:cNvSpPr txBox="1"/>
+          <p:nvPr/>
+        </p:nvSpPr>
+        <p:spPr>
+          <a:xfrm>
+            <a:off x="9144000" y="2148840"/>
+            <a:ext cx="2194560" cy="411480"/>
+          </a:xfrm>
+          <a:prstGeom prst="rect">
+            <a:avLst/>
+          </a:prstGeom>
+          <a:noFill/>
+        </p:spPr>
+        <p:txBody>
+          <a:bodyPr wrap="none">
+            <a:spAutoFit/>
+          </a:bodyPr>
+          <a:lstStyle/>
+          <a:p>
+            <a:pPr>
+              <a:defRPr sz="1100" b="1">
+                <a:solidFill>
+                  <a:srgbClr val="38BDF8"/>
+                </a:solidFill>
+                <a:latin typeface="Arial"/>
+              </a:defRPr>
+            </a:pPr>
+            <a:r>
+              <a:t>04 / GROUNDED SYNTHESIS</a:t>
+            </a:r>
+          </a:p>
+        </p:txBody>
+      </p:sp>
+      <p:sp>
+        <p:nvSpPr>
+          <p:cNvPr id="16" name="TextBox 15"/>
+          <p:cNvSpPr txBox="1"/>
+          <p:nvPr/>
+        </p:nvSpPr>
+        <p:spPr>
+          <a:xfrm>
+            <a:off x="9098280" y="2606040"/>
+            <a:ext cx="2286000" cy="3383280"/>
+          </a:xfrm>
+          <a:prstGeom prst="rect">
+            <a:avLst/>
+          </a:prstGeom>
+          <a:noFill/>
+        </p:spPr>
+        <p:txBody>
+          <a:bodyPr wrap="square">
+            <a:spAutoFit/>
+          </a:bodyPr>
+          <a:lstStyle/>
+          <a:p>
+            <a:pPr>
+              <a:spcAft>
+                <a:spcPts val="1000"/>
+              </a:spcAft>
+              <a:defRPr sz="1400" b="1">
+                <a:solidFill>
+                  <a:srgbClr val="FFFFFF"/>
+                </a:solidFill>
+              </a:defRPr>
+            </a:pPr>
+            <a:r>
+              <a:t>FastEmbed &amp; Streamlit</a:t>
+            </a:r>
+          </a:p>
+          <a:p>
+            <a:pPr>
+              <a:spcAft>
+                <a:spcPts val="500"/>
+              </a:spcAft>
+              <a:defRPr sz="1150">
+                <a:solidFill>
+                  <a:srgbClr val="94A3B8"/>
+                </a:solidFill>
+              </a:defRPr>
+            </a:pPr>
+            <a:r>
+              <a:t>• Semantic vector extraction of ESG audit documents (-42% water certification).</a:t>
+            </a:r>
+          </a:p>
+          <a:p>
+            <a:pPr>
+              <a:spcAft>
+                <a:spcPts val="500"/>
+              </a:spcAft>
+              <a:defRPr sz="1150">
+                <a:solidFill>
+                  <a:srgbClr val="94A3B8"/>
+                </a:solidFill>
+              </a:defRPr>
+            </a:pPr>
+            <a:r>
+              <a:t>• Multi-factor evidence tagged as [FACT], [CALCULATION], or [REASONING].</a:t>
+            </a:r>
+          </a:p>
+          <a:p>
+            <a:pPr>
+              <a:spcAft>
+                <a:spcPts val="500"/>
+              </a:spcAft>
+              <a:defRPr sz="1150">
+                <a:solidFill>
+                  <a:srgbClr val="94A3B8"/>
+                </a:solidFill>
+              </a:defRPr>
+            </a:pPr>
+            <a:r>
+              <a:t>• Enterprise-grade terminal interface delivering 14-second decisions.</a:t>
             </a:r>
           </a:p>
         </p:txBody>
@@ -4607,8 +4859,44 @@
         </p:nvSpPr>
         <p:spPr>
           <a:xfrm>
-            <a:off x="731520" y="457200"/>
-            <a:ext cx="10698480" cy="365760"/>
+            <a:off x="731520" y="411480"/>
+            <a:ext cx="10698480" cy="320040"/>
+          </a:xfrm>
+          <a:prstGeom prst="rect">
+            <a:avLst/>
+          </a:prstGeom>
+          <a:noFill/>
+        </p:spPr>
+        <p:txBody>
+          <a:bodyPr wrap="none">
+            <a:spAutoFit/>
+          </a:bodyPr>
+          <a:lstStyle/>
+          <a:p>
+            <a:pPr>
+              <a:defRPr sz="1100" b="1">
+                <a:solidFill>
+                  <a:srgbClr val="38BDF8"/>
+                </a:solidFill>
+                <a:latin typeface="Arial"/>
+              </a:defRPr>
+            </a:pPr>
+            <a:r>
+              <a:t>LIVE DEMONSTRATION</a:t>
+            </a:r>
+          </a:p>
+        </p:txBody>
+      </p:sp>
+      <p:sp>
+        <p:nvSpPr>
+          <p:cNvPr id="4" name="TextBox 3"/>
+          <p:cNvSpPr txBox="1"/>
+          <p:nvPr/>
+        </p:nvSpPr>
+        <p:spPr>
+          <a:xfrm>
+            <a:off x="731520" y="777240"/>
+            <a:ext cx="10698480" cy="914400"/>
           </a:xfrm>
           <a:prstGeom prst="rect">
             <a:avLst/>
@@ -4622,64 +4910,28 @@
           <a:lstStyle/>
           <a:p>
             <a:pPr>
-              <a:defRPr sz="1000" b="1">
-                <a:solidFill>
-                  <a:srgbClr val="38BDF8"/>
+              <a:defRPr sz="2800" b="1">
+                <a:solidFill>
+                  <a:srgbClr val="FFFFFF"/>
                 </a:solidFill>
                 <a:latin typeface="Arial"/>
               </a:defRPr>
             </a:pPr>
             <a:r>
-              <a:t>SYSTEM ARCHITECTURE</a:t>
-            </a:r>
-          </a:p>
-        </p:txBody>
-      </p:sp>
-      <p:sp>
-        <p:nvSpPr>
-          <p:cNvPr id="4" name="TextBox 3"/>
-          <p:cNvSpPr txBox="1"/>
-          <p:nvPr/>
-        </p:nvSpPr>
-        <p:spPr>
-          <a:xfrm>
-            <a:off x="731520" y="777240"/>
-            <a:ext cx="10698480" cy="731520"/>
-          </a:xfrm>
-          <a:prstGeom prst="rect">
-            <a:avLst/>
-          </a:prstGeom>
-          <a:noFill/>
-        </p:spPr>
-        <p:txBody>
-          <a:bodyPr wrap="square">
-            <a:spAutoFit/>
-          </a:bodyPr>
-          <a:lstStyle/>
-          <a:p>
-            <a:pPr>
-              <a:defRPr sz="2400" b="1">
-                <a:solidFill>
-                  <a:srgbClr val="FFFFFF"/>
+              <a:t>EcoTex Milano: Pre-Underwritten in 14 Seconds</a:t>
+            </a:r>
+          </a:p>
+          <a:p>
+            <a:pPr>
+              <a:defRPr sz="1400">
+                <a:solidFill>
+                  <a:srgbClr val="94A3B8"/>
                 </a:solidFill>
                 <a:latin typeface="Arial"/>
               </a:defRPr>
             </a:pPr>
             <a:r>
-              <a:t>The Golden Rule: The LLM is NOT the Calculator</a:t>
-            </a:r>
-          </a:p>
-          <a:p>
-            <a:pPr>
-              <a:defRPr sz="1300">
-                <a:solidFill>
-                  <a:srgbClr val="94A3B8"/>
-                </a:solidFill>
-                <a:latin typeface="Arial"/>
-              </a:defRPr>
-            </a:pPr>
-            <a:r>
-              <a:t>Deterministic truth computes the score. The AI engine orchestrates and explains.</a:t>
+              <a:t>Discovering bankability and optimizing borrowing limits before formal bank application.</a:t>
             </a:r>
           </a:p>
         </p:txBody>
@@ -4693,7 +4945,7 @@
         <p:spPr>
           <a:xfrm>
             <a:off x="731520" y="1920240"/>
-            <a:ext cx="5120640" cy="4297680"/>
+            <a:ext cx="2560320" cy="1645920"/>
           </a:xfrm>
           <a:prstGeom prst="roundRect">
             <a:avLst/>
@@ -4703,7 +4955,7 @@
           </a:solidFill>
           <a:ln w="19050">
             <a:solidFill>
-              <a:srgbClr val="10B981"/>
+              <a:srgbClr val="1F2937"/>
             </a:solidFill>
           </a:ln>
         </p:spPr>
@@ -4737,44 +4989,8 @@
         </p:nvSpPr>
         <p:spPr>
           <a:xfrm>
-            <a:off x="914400" y="2057400"/>
-            <a:ext cx="4754880" cy="457200"/>
-          </a:xfrm>
-          <a:prstGeom prst="rect">
-            <a:avLst/>
-          </a:prstGeom>
-          <a:noFill/>
-        </p:spPr>
-        <p:txBody>
-          <a:bodyPr wrap="none">
-            <a:spAutoFit/>
-          </a:bodyPr>
-          <a:lstStyle/>
-          <a:p>
-            <a:pPr>
-              <a:defRPr sz="1100" b="1">
-                <a:solidFill>
-                  <a:srgbClr val="38BDF8"/>
-                </a:solidFill>
-                <a:latin typeface="Arial"/>
-              </a:defRPr>
-            </a:pPr>
-            <a:r>
-              <a:t>DETERMINISTIC CORE (ZERO HALLUCINATION)</a:t>
-            </a:r>
-          </a:p>
-        </p:txBody>
-      </p:sp>
-      <p:sp>
-        <p:nvSpPr>
-          <p:cNvPr id="7" name="TextBox 6"/>
-          <p:cNvSpPr txBox="1"/>
-          <p:nvPr/>
-        </p:nvSpPr>
-        <p:spPr>
-          <a:xfrm>
-            <a:off x="914400" y="2560320"/>
-            <a:ext cx="4754880" cy="3474720"/>
+            <a:off x="868680" y="2011680"/>
+            <a:ext cx="2286000" cy="1463040"/>
           </a:xfrm>
           <a:prstGeom prst="rect">
             <a:avLst/>
@@ -4788,91 +5004,52 @@
           <a:lstStyle/>
           <a:p>
             <a:pPr>
-              <a:spcAft>
-                <a:spcPts val="1000"/>
-              </a:spcAft>
-              <a:defRPr sz="1500" b="1">
-                <a:solidFill>
-                  <a:srgbClr val="10B981"/>
-                </a:solidFill>
-              </a:defRPr>
-            </a:pPr>
-            <a:r>
-              <a:t>Mathematical &amp; Rule-Based Analytics</a:t>
-            </a:r>
-          </a:p>
-          <a:p>
-            <a:pPr>
-              <a:spcAft>
-                <a:spcPts val="800"/>
-              </a:spcAft>
-              <a:defRPr sz="1200">
-                <a:solidFill>
-                  <a:srgbClr val="FFFFFF"/>
-                </a:solidFill>
-              </a:defRPr>
-            </a:pPr>
-            <a:r>
-              <a:t>• Structured Ingestion: DuckDB high-performance columnar engine</a:t>
-            </a:r>
-          </a:p>
-          <a:p>
-            <a:pPr>
-              <a:spcAft>
-                <a:spcPts val="800"/>
-              </a:spcAft>
-              <a:defRPr sz="1200">
-                <a:solidFill>
-                  <a:srgbClr val="FFFFFF"/>
-                </a:solidFill>
-              </a:defRPr>
-            </a:pPr>
-            <a:r>
-              <a:t>• Quantitative Scoring: Liquidity (25%), Leverage (25%), Growth (20%), Sector (15%), Regional (15%)</a:t>
-            </a:r>
-          </a:p>
-          <a:p>
-            <a:pPr>
-              <a:spcAft>
-                <a:spcPts val="800"/>
-              </a:spcAft>
-              <a:defRPr sz="1200">
-                <a:solidFill>
-                  <a:srgbClr val="FFFFFF"/>
-                </a:solidFill>
-              </a:defRPr>
-            </a:pPr>
-            <a:r>
-              <a:t>• Sensitivity Engine: Formulaic DSCR &amp; Debt/EBITDA models</a:t>
-            </a:r>
-          </a:p>
-          <a:p>
-            <a:pPr>
-              <a:spcAft>
-                <a:spcPts val="800"/>
-              </a:spcAft>
-              <a:defRPr sz="1200">
-                <a:solidFill>
-                  <a:srgbClr val="FFFFFF"/>
-                </a:solidFill>
-              </a:defRPr>
-            </a:pPr>
-            <a:r>
-              <a:t>• Regulatory Consistency: Same input guarantees exact same score every single execution run</a:t>
-            </a:r>
-          </a:p>
-        </p:txBody>
-      </p:sp>
-      <p:sp>
-        <p:nvSpPr>
-          <p:cNvPr id="8" name="Rounded Rectangle 7"/>
+              <a:defRPr sz="900">
+                <a:solidFill>
+                  <a:srgbClr val="94A3B8"/>
+                </a:solidFill>
+              </a:defRPr>
+            </a:pPr>
+            <a:r>
+              <a:t>FINANCIAL HEALTH</a:t>
+            </a:r>
+          </a:p>
+          <a:p>
+            <a:pPr>
+              <a:defRPr sz="2400" b="1">
+                <a:solidFill>
+                  <a:srgbClr val="38BDF8"/>
+                </a:solidFill>
+              </a:defRPr>
+            </a:pPr>
+            <a:r>
+              <a:t>82 / 100</a:t>
+            </a:r>
+          </a:p>
+          <a:p>
+            <a:pPr>
+              <a:defRPr sz="1000">
+                <a:solidFill>
+                  <a:srgbClr val="94A3B8"/>
+                </a:solidFill>
+              </a:defRPr>
+            </a:pPr>
+            <a:r>
+              <a:t>Prime Solvency</a:t>
+            </a:r>
+          </a:p>
+        </p:txBody>
+      </p:sp>
+      <p:sp>
+        <p:nvSpPr>
+          <p:cNvPr id="7" name="Rounded Rectangle 6"/>
           <p:cNvSpPr/>
           <p:nvPr/>
         </p:nvSpPr>
         <p:spPr>
           <a:xfrm>
-            <a:off x="6217920" y="1920240"/>
-            <a:ext cx="5212080" cy="4297680"/>
+            <a:off x="3474720" y="1920240"/>
+            <a:ext cx="2560320" cy="1645920"/>
           </a:xfrm>
           <a:prstGeom prst="roundRect">
             <a:avLst/>
@@ -4882,7 +5059,7 @@
           </a:solidFill>
           <a:ln w="19050">
             <a:solidFill>
-              <a:srgbClr val="38BDF8"/>
+              <a:srgbClr val="1F2937"/>
             </a:solidFill>
           </a:ln>
         </p:spPr>
@@ -4910,14 +5087,326 @@
       </p:sp>
       <p:sp>
         <p:nvSpPr>
-          <p:cNvPr id="9" name="TextBox 8"/>
+          <p:cNvPr id="8" name="TextBox 7"/>
           <p:cNvSpPr txBox="1"/>
           <p:nvPr/>
         </p:nvSpPr>
         <p:spPr>
           <a:xfrm>
-            <a:off x="6400800" y="2057400"/>
-            <a:ext cx="4846320" cy="457200"/>
+            <a:off x="3611880" y="2011680"/>
+            <a:ext cx="2286000" cy="1463040"/>
+          </a:xfrm>
+          <a:prstGeom prst="rect">
+            <a:avLst/>
+          </a:prstGeom>
+          <a:noFill/>
+        </p:spPr>
+        <p:txBody>
+          <a:bodyPr wrap="square">
+            <a:spAutoFit/>
+          </a:bodyPr>
+          <a:lstStyle/>
+          <a:p>
+            <a:pPr>
+              <a:defRPr sz="900">
+                <a:solidFill>
+                  <a:srgbClr val="94A3B8"/>
+                </a:solidFill>
+              </a:defRPr>
+            </a:pPr>
+            <a:r>
+              <a:t>ESG ALIGNMENT</a:t>
+            </a:r>
+          </a:p>
+          <a:p>
+            <a:pPr>
+              <a:defRPr sz="2400" b="1">
+                <a:solidFill>
+                  <a:srgbClr val="10B981"/>
+                </a:solidFill>
+              </a:defRPr>
+            </a:pPr>
+            <a:r>
+              <a:t>91 / 100</a:t>
+            </a:r>
+          </a:p>
+          <a:p>
+            <a:pPr>
+              <a:defRPr sz="1000">
+                <a:solidFill>
+                  <a:srgbClr val="94A3B8"/>
+                </a:solidFill>
+              </a:defRPr>
+            </a:pPr>
+            <a:r>
+              <a:t>Top Decile Green</a:t>
+            </a:r>
+          </a:p>
+        </p:txBody>
+      </p:sp>
+      <p:sp>
+        <p:nvSpPr>
+          <p:cNvPr id="9" name="Rounded Rectangle 8"/>
+          <p:cNvSpPr/>
+          <p:nvPr/>
+        </p:nvSpPr>
+        <p:spPr>
+          <a:xfrm>
+            <a:off x="6217920" y="1920240"/>
+            <a:ext cx="2560320" cy="1645920"/>
+          </a:xfrm>
+          <a:prstGeom prst="roundRect">
+            <a:avLst/>
+          </a:prstGeom>
+          <a:solidFill>
+            <a:srgbClr val="111827"/>
+          </a:solidFill>
+          <a:ln w="19050">
+            <a:solidFill>
+              <a:srgbClr val="1F2937"/>
+            </a:solidFill>
+          </a:ln>
+        </p:spPr>
+        <p:style>
+          <a:lnRef idx="1">
+            <a:schemeClr val="accent1"/>
+          </a:lnRef>
+          <a:fillRef idx="3">
+            <a:schemeClr val="accent1"/>
+          </a:fillRef>
+          <a:effectRef idx="2">
+            <a:schemeClr val="accent1"/>
+          </a:effectRef>
+          <a:fontRef idx="minor">
+            <a:schemeClr val="lt1"/>
+          </a:fontRef>
+        </p:style>
+        <p:txBody>
+          <a:bodyPr rtlCol="0" anchor="ctr"/>
+          <a:lstStyle/>
+          <a:p>
+            <a:pPr algn="ctr"/>
+          </a:p>
+        </p:txBody>
+      </p:sp>
+      <p:sp>
+        <p:nvSpPr>
+          <p:cNvPr id="10" name="TextBox 9"/>
+          <p:cNvSpPr txBox="1"/>
+          <p:nvPr/>
+        </p:nvSpPr>
+        <p:spPr>
+          <a:xfrm>
+            <a:off x="6355080" y="2011680"/>
+            <a:ext cx="2286000" cy="1463040"/>
+          </a:xfrm>
+          <a:prstGeom prst="rect">
+            <a:avLst/>
+          </a:prstGeom>
+          <a:noFill/>
+        </p:spPr>
+        <p:txBody>
+          <a:bodyPr wrap="square">
+            <a:spAutoFit/>
+          </a:bodyPr>
+          <a:lstStyle/>
+          <a:p>
+            <a:pPr>
+              <a:defRPr sz="900">
+                <a:solidFill>
+                  <a:srgbClr val="94A3B8"/>
+                </a:solidFill>
+              </a:defRPr>
+            </a:pPr>
+            <a:r>
+              <a:t>TERRITORIAL RISK</a:t>
+            </a:r>
+          </a:p>
+          <a:p>
+            <a:pPr>
+              <a:defRPr sz="2400" b="1">
+                <a:solidFill>
+                  <a:srgbClr val="F59E0B"/>
+                </a:solidFill>
+              </a:defRPr>
+            </a:pPr>
+            <a:r>
+              <a:t>1.82%</a:t>
+            </a:r>
+          </a:p>
+          <a:p>
+            <a:pPr>
+              <a:defRPr sz="1000">
+                <a:solidFill>
+                  <a:srgbClr val="94A3B8"/>
+                </a:solidFill>
+              </a:defRPr>
+            </a:pPr>
+            <a:r>
+              <a:t>Milan Default Benchmark</a:t>
+            </a:r>
+          </a:p>
+        </p:txBody>
+      </p:sp>
+      <p:sp>
+        <p:nvSpPr>
+          <p:cNvPr id="11" name="Rounded Rectangle 10"/>
+          <p:cNvSpPr/>
+          <p:nvPr/>
+        </p:nvSpPr>
+        <p:spPr>
+          <a:xfrm>
+            <a:off x="8961120" y="1920240"/>
+            <a:ext cx="2560320" cy="1645920"/>
+          </a:xfrm>
+          <a:prstGeom prst="roundRect">
+            <a:avLst/>
+          </a:prstGeom>
+          <a:solidFill>
+            <a:srgbClr val="111827"/>
+          </a:solidFill>
+          <a:ln w="19050">
+            <a:solidFill>
+              <a:srgbClr val="1F2937"/>
+            </a:solidFill>
+          </a:ln>
+        </p:spPr>
+        <p:style>
+          <a:lnRef idx="1">
+            <a:schemeClr val="accent1"/>
+          </a:lnRef>
+          <a:fillRef idx="3">
+            <a:schemeClr val="accent1"/>
+          </a:fillRef>
+          <a:effectRef idx="2">
+            <a:schemeClr val="accent1"/>
+          </a:effectRef>
+          <a:fontRef idx="minor">
+            <a:schemeClr val="lt1"/>
+          </a:fontRef>
+        </p:style>
+        <p:txBody>
+          <a:bodyPr rtlCol="0" anchor="ctr"/>
+          <a:lstStyle/>
+          <a:p>
+            <a:pPr algn="ctr"/>
+          </a:p>
+        </p:txBody>
+      </p:sp>
+      <p:sp>
+        <p:nvSpPr>
+          <p:cNvPr id="12" name="TextBox 11"/>
+          <p:cNvSpPr txBox="1"/>
+          <p:nvPr/>
+        </p:nvSpPr>
+        <p:spPr>
+          <a:xfrm>
+            <a:off x="9098280" y="2011680"/>
+            <a:ext cx="2286000" cy="1463040"/>
+          </a:xfrm>
+          <a:prstGeom prst="rect">
+            <a:avLst/>
+          </a:prstGeom>
+          <a:noFill/>
+        </p:spPr>
+        <p:txBody>
+          <a:bodyPr wrap="square">
+            <a:spAutoFit/>
+          </a:bodyPr>
+          <a:lstStyle/>
+          <a:p>
+            <a:pPr>
+              <a:defRPr sz="900">
+                <a:solidFill>
+                  <a:srgbClr val="94A3B8"/>
+                </a:solidFill>
+              </a:defRPr>
+            </a:pPr>
+            <a:r>
+              <a:t>BANKABILITY OUTCOME</a:t>
+            </a:r>
+          </a:p>
+          <a:p>
+            <a:pPr>
+              <a:defRPr sz="2400" b="1">
+                <a:solidFill>
+                  <a:srgbClr val="10B981"/>
+                </a:solidFill>
+              </a:defRPr>
+            </a:pPr>
+            <a:r>
+              <a:t>APPROVE</a:t>
+            </a:r>
+          </a:p>
+          <a:p>
+            <a:pPr>
+              <a:defRPr sz="1000">
+                <a:solidFill>
+                  <a:srgbClr val="94A3B8"/>
+                </a:solidFill>
+              </a:defRPr>
+            </a:pPr>
+            <a:r>
+              <a:t>5.15% Prime Rate</a:t>
+            </a:r>
+          </a:p>
+        </p:txBody>
+      </p:sp>
+      <p:sp>
+        <p:nvSpPr>
+          <p:cNvPr id="13" name="Rounded Rectangle 12"/>
+          <p:cNvSpPr/>
+          <p:nvPr/>
+        </p:nvSpPr>
+        <p:spPr>
+          <a:xfrm>
+            <a:off x="731520" y="3840480"/>
+            <a:ext cx="10698480" cy="2377440"/>
+          </a:xfrm>
+          <a:prstGeom prst="roundRect">
+            <a:avLst/>
+          </a:prstGeom>
+          <a:solidFill>
+            <a:srgbClr val="111827"/>
+          </a:solidFill>
+          <a:ln w="19050">
+            <a:solidFill>
+              <a:srgbClr val="1F2937"/>
+            </a:solidFill>
+          </a:ln>
+        </p:spPr>
+        <p:style>
+          <a:lnRef idx="1">
+            <a:schemeClr val="accent1"/>
+          </a:lnRef>
+          <a:fillRef idx="3">
+            <a:schemeClr val="accent1"/>
+          </a:fillRef>
+          <a:effectRef idx="2">
+            <a:schemeClr val="accent1"/>
+          </a:effectRef>
+          <a:fontRef idx="minor">
+            <a:schemeClr val="lt1"/>
+          </a:fontRef>
+        </p:style>
+        <p:txBody>
+          <a:bodyPr rtlCol="0" anchor="ctr"/>
+          <a:lstStyle/>
+          <a:p>
+            <a:pPr algn="ctr"/>
+          </a:p>
+        </p:txBody>
+      </p:sp>
+      <p:sp>
+        <p:nvSpPr>
+          <p:cNvPr id="14" name="TextBox 13"/>
+          <p:cNvSpPr txBox="1"/>
+          <p:nvPr/>
+        </p:nvSpPr>
+        <p:spPr>
+          <a:xfrm>
+            <a:off x="914400" y="3977640"/>
+            <a:ext cx="10332720" cy="411480"/>
           </a:xfrm>
           <a:prstGeom prst="rect">
             <a:avLst/>
@@ -4939,21 +5428,21 @@
               </a:defRPr>
             </a:pPr>
             <a:r>
-              <a:t>AI &amp; EVIDENCE ENGINE (SEMANTIC RIGOR)</a:t>
-            </a:r>
-          </a:p>
-        </p:txBody>
-      </p:sp>
-      <p:sp>
-        <p:nvSpPr>
-          <p:cNvPr id="10" name="TextBox 9"/>
+              <a:t>INTERACTIVE WHAT-IF OPTIMIZER (€750K VS €1.0M TIPPING POINT)</a:t>
+            </a:r>
+          </a:p>
+        </p:txBody>
+      </p:sp>
+      <p:sp>
+        <p:nvSpPr>
+          <p:cNvPr id="15" name="TextBox 14"/>
           <p:cNvSpPr txBox="1"/>
           <p:nvPr/>
         </p:nvSpPr>
         <p:spPr>
           <a:xfrm>
-            <a:off x="6400800" y="2560320"/>
-            <a:ext cx="4846320" cy="3474720"/>
+            <a:off x="914400" y="4297680"/>
+            <a:ext cx="10332720" cy="1828800"/>
           </a:xfrm>
           <a:prstGeom prst="rect">
             <a:avLst/>
@@ -4968,16 +5457,16 @@
           <a:p>
             <a:pPr>
               <a:spcAft>
-                <a:spcPts val="1000"/>
+                <a:spcPts val="800"/>
               </a:spcAft>
-              <a:defRPr sz="1500" b="1">
-                <a:solidFill>
-                  <a:srgbClr val="38BDF8"/>
-                </a:solidFill>
-              </a:defRPr>
-            </a:pPr>
-            <a:r>
-              <a:t>Context Synthesis &amp; Tool Routing</a:t>
+              <a:defRPr sz="1300" b="1">
+                <a:solidFill>
+                  <a:srgbClr val="10B981"/>
+                </a:solidFill>
+              </a:defRPr>
+            </a:pPr>
+            <a:r>
+              <a:t>OPTIMAL BASE (€750,000): DSCR 1.68x | Health 82/100 | Outcome: APPROVE at prime rate + 15% regional grant.</a:t>
             </a:r>
           </a:p>
           <a:p>
@@ -4985,6 +5474,18 @@
               <a:spcAft>
                 <a:spcPts val="800"/>
               </a:spcAft>
+              <a:defRPr sz="1300" b="1">
+                <a:solidFill>
+                  <a:srgbClr val="F59E0B"/>
+                </a:solidFill>
+              </a:defRPr>
+            </a:pPr>
+            <a:r>
+              <a:t>STRESS SCENARIO (€1,000,000): DSCR drops to 1.28x (breaches covenant) | Health drops to 74 | Outcome: REVIEW.</a:t>
+            </a:r>
+          </a:p>
+          <a:p>
+            <a:pPr>
               <a:defRPr sz="1200">
                 <a:solidFill>
                   <a:srgbClr val="FFFFFF"/>
@@ -4992,52 +5493,7 @@
               </a:defRPr>
             </a:pPr>
             <a:r>
-              <a:t>• Hybrid RAG: Chunking &amp; semantic search over audit disclosures</a:t>
-            </a:r>
-          </a:p>
-          <a:p>
-            <a:pPr>
-              <a:spcAft>
-                <a:spcPts val="800"/>
-              </a:spcAft>
-              <a:defRPr sz="1200">
-                <a:solidFill>
-                  <a:srgbClr val="FFFFFF"/>
-                </a:solidFill>
-              </a:defRPr>
-            </a:pPr>
-            <a:r>
-              <a:t>• Public Benchmark Routing: Banca d'Italia + Open Data Lombardia</a:t>
-            </a:r>
-          </a:p>
-          <a:p>
-            <a:pPr>
-              <a:spcAft>
-                <a:spcPts val="800"/>
-              </a:spcAft>
-              <a:defRPr sz="1200">
-                <a:solidFill>
-                  <a:srgbClr val="FFFFFF"/>
-                </a:solidFill>
-              </a:defRPr>
-            </a:pPr>
-            <a:r>
-              <a:t>• Synthesis Layer: Translates quantitative data into RM rationale</a:t>
-            </a:r>
-          </a:p>
-          <a:p>
-            <a:pPr>
-              <a:spcAft>
-                <a:spcPts val="800"/>
-              </a:spcAft>
-              <a:defRPr sz="1200">
-                <a:solidFill>
-                  <a:srgbClr val="FFFFFF"/>
-                </a:solidFill>
-              </a:defRPr>
-            </a:pPr>
-            <a:r>
-              <a:t>• Strict Governance: Categorizes outputs into FACT, CALCULATION, and REASONING</a:t>
+              <a:t>ACTIONABLE CFO GUIDANCE: Avoid applying for €1.0M debt directly. Structure request as €750k loan + €250k regional grant to preserve prime pricing and ensure 100% bank approval.</a:t>
             </a:r>
           </a:p>
         </p:txBody>
@@ -5113,8 +5569,44 @@
         </p:nvSpPr>
         <p:spPr>
           <a:xfrm>
-            <a:off x="731520" y="457200"/>
-            <a:ext cx="10698480" cy="365760"/>
+            <a:off x="731520" y="411480"/>
+            <a:ext cx="10698480" cy="320040"/>
+          </a:xfrm>
+          <a:prstGeom prst="rect">
+            <a:avLst/>
+          </a:prstGeom>
+          <a:noFill/>
+        </p:spPr>
+        <p:txBody>
+          <a:bodyPr wrap="none">
+            <a:spAutoFit/>
+          </a:bodyPr>
+          <a:lstStyle/>
+          <a:p>
+            <a:pPr>
+              <a:defRPr sz="1100" b="1">
+                <a:solidFill>
+                  <a:srgbClr val="38BDF8"/>
+                </a:solidFill>
+                <a:latin typeface="Arial"/>
+              </a:defRPr>
+            </a:pPr>
+            <a:r>
+              <a:t>COMMERCIAL STRATEGY</a:t>
+            </a:r>
+          </a:p>
+        </p:txBody>
+      </p:sp>
+      <p:sp>
+        <p:nvSpPr>
+          <p:cNvPr id="4" name="TextBox 3"/>
+          <p:cNvSpPr txBox="1"/>
+          <p:nvPr/>
+        </p:nvSpPr>
+        <p:spPr>
+          <a:xfrm>
+            <a:off x="731520" y="777240"/>
+            <a:ext cx="10698480" cy="914400"/>
           </a:xfrm>
           <a:prstGeom prst="rect">
             <a:avLst/>
@@ -5128,64 +5620,28 @@
           <a:lstStyle/>
           <a:p>
             <a:pPr>
-              <a:defRPr sz="1000" b="1">
-                <a:solidFill>
-                  <a:srgbClr val="38BDF8"/>
+              <a:defRPr sz="2800" b="1">
+                <a:solidFill>
+                  <a:srgbClr val="FFFFFF"/>
                 </a:solidFill>
                 <a:latin typeface="Arial"/>
               </a:defRPr>
             </a:pPr>
             <a:r>
-              <a:t>LIVE EXECUTION PROOF</a:t>
-            </a:r>
-          </a:p>
-        </p:txBody>
-      </p:sp>
-      <p:sp>
-        <p:nvSpPr>
-          <p:cNvPr id="4" name="TextBox 3"/>
-          <p:cNvSpPr txBox="1"/>
-          <p:nvPr/>
-        </p:nvSpPr>
-        <p:spPr>
-          <a:xfrm>
-            <a:off x="731520" y="777240"/>
-            <a:ext cx="10698480" cy="731520"/>
-          </a:xfrm>
-          <a:prstGeom prst="rect">
-            <a:avLst/>
-          </a:prstGeom>
-          <a:noFill/>
-        </p:spPr>
-        <p:txBody>
-          <a:bodyPr wrap="square">
-            <a:spAutoFit/>
-          </a:bodyPr>
-          <a:lstStyle/>
-          <a:p>
-            <a:pPr>
-              <a:defRPr sz="2400" b="1">
-                <a:solidFill>
-                  <a:srgbClr val="FFFFFF"/>
+              <a:t>Business Model: High Margin, Low CAC, Self-Funding Value</a:t>
+            </a:r>
+          </a:p>
+          <a:p>
+            <a:pPr>
+              <a:defRPr sz="1400">
+                <a:solidFill>
+                  <a:srgbClr val="94A3B8"/>
                 </a:solidFill>
                 <a:latin typeface="Arial"/>
               </a:defRPr>
             </a:pPr>
             <a:r>
-              <a:t>Base Case: EcoTex Milano €750k Facility Evaluation</a:t>
-            </a:r>
-          </a:p>
-          <a:p>
-            <a:pPr>
-              <a:defRPr sz="1300">
-                <a:solidFill>
-                  <a:srgbClr val="94A3B8"/>
-                </a:solidFill>
-                <a:latin typeface="Arial"/>
-              </a:defRPr>
-            </a:pPr>
-            <a:r>
-              <a:t>Evaluating equipment financing for sustainable dyeing &amp; closed-loop water recycling.</a:t>
+              <a:t>Transparent pricing for SMEs with highly profitable B2B2C accounting distribution.</a:t>
             </a:r>
           </a:p>
         </p:txBody>
@@ -5198,8 +5654,8 @@
         </p:nvSpPr>
         <p:spPr>
           <a:xfrm>
-            <a:off x="731520" y="1828800"/>
-            <a:ext cx="2560320" cy="1645920"/>
+            <a:off x="731520" y="2011680"/>
+            <a:ext cx="3383280" cy="4114800"/>
           </a:xfrm>
           <a:prstGeom prst="roundRect">
             <a:avLst/>
@@ -5209,7 +5665,7 @@
           </a:solidFill>
           <a:ln w="19050">
             <a:solidFill>
-              <a:srgbClr val="1F2937"/>
+              <a:srgbClr val="2563EB"/>
             </a:solidFill>
           </a:ln>
         </p:spPr>
@@ -5243,8 +5699,44 @@
         </p:nvSpPr>
         <p:spPr>
           <a:xfrm>
-            <a:off x="868680" y="1920240"/>
-            <a:ext cx="2286000" cy="1463040"/>
+            <a:off x="914400" y="2148840"/>
+            <a:ext cx="3017520" cy="411480"/>
+          </a:xfrm>
+          <a:prstGeom prst="rect">
+            <a:avLst/>
+          </a:prstGeom>
+          <a:noFill/>
+        </p:spPr>
+        <p:txBody>
+          <a:bodyPr wrap="none">
+            <a:spAutoFit/>
+          </a:bodyPr>
+          <a:lstStyle/>
+          <a:p>
+            <a:pPr>
+              <a:defRPr sz="1100" b="1">
+                <a:solidFill>
+                  <a:srgbClr val="38BDF8"/>
+                </a:solidFill>
+                <a:latin typeface="Arial"/>
+              </a:defRPr>
+            </a:pPr>
+            <a:r>
+              <a:t>THE PRICING MODEL</a:t>
+            </a:r>
+          </a:p>
+        </p:txBody>
+      </p:sp>
+      <p:sp>
+        <p:nvSpPr>
+          <p:cNvPr id="7" name="TextBox 6"/>
+          <p:cNvSpPr txBox="1"/>
+          <p:nvPr/>
+        </p:nvSpPr>
+        <p:spPr>
+          <a:xfrm>
+            <a:off x="914400" y="2606040"/>
+            <a:ext cx="3017520" cy="3383280"/>
           </a:xfrm>
           <a:prstGeom prst="rect">
             <a:avLst/>
@@ -5258,52 +5750,91 @@
           <a:lstStyle/>
           <a:p>
             <a:pPr>
-              <a:defRPr sz="900">
+              <a:spcAft>
+                <a:spcPts val="1000"/>
+              </a:spcAft>
+              <a:defRPr sz="1500" b="1">
+                <a:solidFill>
+                  <a:srgbClr val="FFFFFF"/>
+                </a:solidFill>
+              </a:defRPr>
+            </a:pPr>
+            <a:r>
+              <a:t>Freemium + Success Fee</a:t>
+            </a:r>
+          </a:p>
+          <a:p>
+            <a:pPr>
+              <a:spcAft>
+                <a:spcPts val="500"/>
+              </a:spcAft>
+              <a:defRPr sz="1200">
                 <a:solidFill>
                   <a:srgbClr val="94A3B8"/>
                 </a:solidFill>
               </a:defRPr>
             </a:pPr>
             <a:r>
-              <a:t>FINANCIAL HEALTH</a:t>
-            </a:r>
-          </a:p>
-          <a:p>
-            <a:pPr>
-              <a:defRPr sz="2400" b="1">
-                <a:solidFill>
-                  <a:srgbClr val="38BDF8"/>
-                </a:solidFill>
-              </a:defRPr>
-            </a:pPr>
-            <a:r>
-              <a:t>82/100</a:t>
-            </a:r>
-          </a:p>
-          <a:p>
-            <a:pPr>
-              <a:defRPr sz="1000">
+              <a:t>• Free Bankability Scan: Instant diagnostic to attract SMEs at zero cost.</a:t>
+            </a:r>
+          </a:p>
+          <a:p>
+            <a:pPr>
+              <a:spcAft>
+                <a:spcPts val="500"/>
+              </a:spcAft>
+              <a:defRPr sz="1200">
                 <a:solidFill>
                   <a:srgbClr val="94A3B8"/>
                 </a:solidFill>
               </a:defRPr>
             </a:pPr>
             <a:r>
-              <a:t>Safe (&gt;70)</a:t>
-            </a:r>
-          </a:p>
-        </p:txBody>
-      </p:sp>
-      <p:sp>
-        <p:nvSpPr>
-          <p:cNvPr id="7" name="Rounded Rectangle 6"/>
+              <a:t>• Success Fee / Dossier Certification: 0.5% - 1.0% paid only upon loan funding.</a:t>
+            </a:r>
+          </a:p>
+          <a:p>
+            <a:pPr>
+              <a:spcAft>
+                <a:spcPts val="500"/>
+              </a:spcAft>
+              <a:defRPr sz="1200">
+                <a:solidFill>
+                  <a:srgbClr val="94A3B8"/>
+                </a:solidFill>
+              </a:defRPr>
+            </a:pPr>
+            <a:r>
+              <a:t>• Average transaction revenue: €3,500 - €7,500 per funded loan dossier.</a:t>
+            </a:r>
+          </a:p>
+          <a:p>
+            <a:pPr>
+              <a:spcAft>
+                <a:spcPts val="500"/>
+              </a:spcAft>
+              <a:defRPr sz="1200">
+                <a:solidFill>
+                  <a:srgbClr val="94A3B8"/>
+                </a:solidFill>
+              </a:defRPr>
+            </a:pPr>
+            <a:r>
+              <a:t>• Pure ROI for the SME: Unlocked interest discount pays for the service 3x over.</a:t>
+            </a:r>
+          </a:p>
+        </p:txBody>
+      </p:sp>
+      <p:sp>
+        <p:nvSpPr>
+          <p:cNvPr id="8" name="Rounded Rectangle 7"/>
           <p:cNvSpPr/>
           <p:nvPr/>
         </p:nvSpPr>
         <p:spPr>
           <a:xfrm>
-            <a:off x="3474720" y="1828800"/>
-            <a:ext cx="2560320" cy="1645920"/>
+            <a:off x="4389120" y="2011680"/>
+            <a:ext cx="3383280" cy="4114800"/>
           </a:xfrm>
           <a:prstGeom prst="roundRect">
             <a:avLst/>
@@ -5313,7 +5844,7 @@
           </a:solidFill>
           <a:ln w="19050">
             <a:solidFill>
-              <a:srgbClr val="1F2937"/>
+              <a:srgbClr val="2563EB"/>
             </a:solidFill>
           </a:ln>
         </p:spPr>
@@ -5341,14 +5872,50 @@
       </p:sp>
       <p:sp>
         <p:nvSpPr>
-          <p:cNvPr id="8" name="TextBox 7"/>
+          <p:cNvPr id="9" name="TextBox 8"/>
           <p:cNvSpPr txBox="1"/>
           <p:nvPr/>
         </p:nvSpPr>
         <p:spPr>
           <a:xfrm>
-            <a:off x="3611880" y="1920240"/>
-            <a:ext cx="2286000" cy="1463040"/>
+            <a:off x="4572000" y="2148840"/>
+            <a:ext cx="3017520" cy="411480"/>
+          </a:xfrm>
+          <a:prstGeom prst="rect">
+            <a:avLst/>
+          </a:prstGeom>
+          <a:noFill/>
+        </p:spPr>
+        <p:txBody>
+          <a:bodyPr wrap="none">
+            <a:spAutoFit/>
+          </a:bodyPr>
+          <a:lstStyle/>
+          <a:p>
+            <a:pPr>
+              <a:defRPr sz="1100" b="1">
+                <a:solidFill>
+                  <a:srgbClr val="38BDF8"/>
+                </a:solidFill>
+                <a:latin typeface="Arial"/>
+              </a:defRPr>
+            </a:pPr>
+            <a:r>
+              <a:t>THE SCALABLE CHANNEL</a:t>
+            </a:r>
+          </a:p>
+        </p:txBody>
+      </p:sp>
+      <p:sp>
+        <p:nvSpPr>
+          <p:cNvPr id="10" name="TextBox 9"/>
+          <p:cNvSpPr txBox="1"/>
+          <p:nvPr/>
+        </p:nvSpPr>
+        <p:spPr>
+          <a:xfrm>
+            <a:off x="4572000" y="2606040"/>
+            <a:ext cx="3017520" cy="3383280"/>
           </a:xfrm>
           <a:prstGeom prst="rect">
             <a:avLst/>
@@ -5362,52 +5929,91 @@
           <a:lstStyle/>
           <a:p>
             <a:pPr>
-              <a:defRPr sz="900">
+              <a:spcAft>
+                <a:spcPts val="1000"/>
+              </a:spcAft>
+              <a:defRPr sz="1500" b="1">
+                <a:solidFill>
+                  <a:srgbClr val="FFFFFF"/>
+                </a:solidFill>
+              </a:defRPr>
+            </a:pPr>
+            <a:r>
+              <a:t>B2B2C Accountant Flywheel</a:t>
+            </a:r>
+          </a:p>
+          <a:p>
+            <a:pPr>
+              <a:spcAft>
+                <a:spcPts val="500"/>
+              </a:spcAft>
+              <a:defRPr sz="1200">
                 <a:solidFill>
                   <a:srgbClr val="94A3B8"/>
                 </a:solidFill>
               </a:defRPr>
             </a:pPr>
             <a:r>
-              <a:t>ESG ALIGNMENT</a:t>
-            </a:r>
-          </a:p>
-          <a:p>
-            <a:pPr>
-              <a:defRPr sz="2400" b="1">
-                <a:solidFill>
-                  <a:srgbClr val="10B981"/>
-                </a:solidFill>
-              </a:defRPr>
-            </a:pPr>
-            <a:r>
-              <a:t>91/100</a:t>
-            </a:r>
-          </a:p>
-          <a:p>
-            <a:pPr>
-              <a:defRPr sz="1000">
+              <a:t>• 120,000 corporate accounting firms in Italy manage SME financing.</a:t>
+            </a:r>
+          </a:p>
+          <a:p>
+            <a:pPr>
+              <a:spcAft>
+                <a:spcPts val="500"/>
+              </a:spcAft>
+              <a:defRPr sz="1200">
                 <a:solidFill>
                   <a:srgbClr val="94A3B8"/>
                 </a:solidFill>
               </a:defRPr>
             </a:pPr>
             <a:r>
-              <a:t>Top Decile</a:t>
-            </a:r>
-          </a:p>
-        </p:txBody>
-      </p:sp>
-      <p:sp>
-        <p:nvSpPr>
-          <p:cNvPr id="9" name="Rounded Rectangle 8"/>
+              <a:t>• FinSight provides a white-label 'Credit Readiness Portal' to accountants.</a:t>
+            </a:r>
+          </a:p>
+          <a:p>
+            <a:pPr>
+              <a:spcAft>
+                <a:spcPts val="500"/>
+              </a:spcAft>
+              <a:defRPr sz="1200">
+                <a:solidFill>
+                  <a:srgbClr val="94A3B8"/>
+                </a:solidFill>
+              </a:defRPr>
+            </a:pPr>
+            <a:r>
+              <a:t>• 1 accounting partner = 25+ SME loan dossiers annually.</a:t>
+            </a:r>
+          </a:p>
+          <a:p>
+            <a:pPr>
+              <a:spcAft>
+                <a:spcPts val="500"/>
+              </a:spcAft>
+              <a:defRPr sz="1200">
+                <a:solidFill>
+                  <a:srgbClr val="94A3B8"/>
+                </a:solidFill>
+              </a:defRPr>
+            </a:pPr>
+            <a:r>
+              <a:t>• Slashes customer acquisition cost (CAC) to under €250 per company.</a:t>
+            </a:r>
+          </a:p>
+        </p:txBody>
+      </p:sp>
+      <p:sp>
+        <p:nvSpPr>
+          <p:cNvPr id="11" name="Rounded Rectangle 10"/>
           <p:cNvSpPr/>
           <p:nvPr/>
         </p:nvSpPr>
         <p:spPr>
           <a:xfrm>
-            <a:off x="6217920" y="1828800"/>
-            <a:ext cx="2560320" cy="1645920"/>
+            <a:off x="8046720" y="2011680"/>
+            <a:ext cx="3383280" cy="4114800"/>
           </a:xfrm>
           <a:prstGeom prst="roundRect">
             <a:avLst/>
@@ -5417,7 +6023,7 @@
           </a:solidFill>
           <a:ln w="19050">
             <a:solidFill>
-              <a:srgbClr val="1F2937"/>
+              <a:srgbClr val="2563EB"/>
             </a:solidFill>
           </a:ln>
         </p:spPr>
@@ -5445,14 +6051,50 @@
       </p:sp>
       <p:sp>
         <p:nvSpPr>
-          <p:cNvPr id="10" name="TextBox 9"/>
+          <p:cNvPr id="12" name="TextBox 11"/>
           <p:cNvSpPr txBox="1"/>
           <p:nvPr/>
         </p:nvSpPr>
         <p:spPr>
           <a:xfrm>
-            <a:off x="6355080" y="1920240"/>
-            <a:ext cx="2286000" cy="1463040"/>
+            <a:off x="8229600" y="2148840"/>
+            <a:ext cx="3017520" cy="411480"/>
+          </a:xfrm>
+          <a:prstGeom prst="rect">
+            <a:avLst/>
+          </a:prstGeom>
+          <a:noFill/>
+        </p:spPr>
+        <p:txBody>
+          <a:bodyPr wrap="none">
+            <a:spAutoFit/>
+          </a:bodyPr>
+          <a:lstStyle/>
+          <a:p>
+            <a:pPr>
+              <a:defRPr sz="1100" b="1">
+                <a:solidFill>
+                  <a:srgbClr val="38BDF8"/>
+                </a:solidFill>
+                <a:latin typeface="Arial"/>
+              </a:defRPr>
+            </a:pPr>
+            <a:r>
+              <a:t>UNIT ECONOMICS</a:t>
+            </a:r>
+          </a:p>
+        </p:txBody>
+      </p:sp>
+      <p:sp>
+        <p:nvSpPr>
+          <p:cNvPr id="13" name="TextBox 12"/>
+          <p:cNvSpPr txBox="1"/>
+          <p:nvPr/>
+        </p:nvSpPr>
+        <p:spPr>
+          <a:xfrm>
+            <a:off x="8229600" y="2606040"/>
+            <a:ext cx="3017520" cy="3383280"/>
           </a:xfrm>
           <a:prstGeom prst="rect">
             <a:avLst/>
@@ -5466,289 +6108,92 @@
           <a:lstStyle/>
           <a:p>
             <a:pPr>
-              <a:defRPr sz="900">
+              <a:spcAft>
+                <a:spcPts val="1000"/>
+              </a:spcAft>
+              <a:defRPr sz="1500" b="1">
+                <a:solidFill>
+                  <a:srgbClr val="FFFFFF"/>
+                </a:solidFill>
+              </a:defRPr>
+            </a:pPr>
+            <a:r>
+              <a:t>Proven Capital Efficiency</a:t>
+            </a:r>
+          </a:p>
+          <a:p>
+            <a:pPr>
+              <a:spcAft>
+                <a:spcPts val="500"/>
+              </a:spcAft>
+              <a:defRPr sz="1200">
                 <a:solidFill>
                   <a:srgbClr val="94A3B8"/>
                 </a:solidFill>
               </a:defRPr>
             </a:pPr>
             <a:r>
-              <a:t>REGIONAL DEFAULT SPREAD</a:t>
-            </a:r>
-          </a:p>
-          <a:p>
-            <a:pPr>
-              <a:defRPr sz="2400" b="1">
-                <a:solidFill>
-                  <a:srgbClr val="F59E0B"/>
-                </a:solidFill>
-              </a:defRPr>
-            </a:pPr>
-            <a:r>
-              <a:t>1.82%</a:t>
-            </a:r>
-          </a:p>
-          <a:p>
-            <a:pPr>
-              <a:defRPr sz="1000">
+              <a:t>• Target Deal Size: €500,000 - €1,500,000</a:t>
+            </a:r>
+          </a:p>
+          <a:p>
+            <a:pPr>
+              <a:spcAft>
+                <a:spcPts val="500"/>
+              </a:spcAft>
+              <a:defRPr sz="1200">
                 <a:solidFill>
                   <a:srgbClr val="94A3B8"/>
                 </a:solidFill>
               </a:defRPr>
             </a:pPr>
             <a:r>
-              <a:t>Milan vs IT 2.95%</a:t>
-            </a:r>
-          </a:p>
-        </p:txBody>
-      </p:sp>
-      <p:sp>
-        <p:nvSpPr>
-          <p:cNvPr id="11" name="Rounded Rectangle 10"/>
-          <p:cNvSpPr/>
-          <p:nvPr/>
-        </p:nvSpPr>
-        <p:spPr>
-          <a:xfrm>
-            <a:off x="8961120" y="1828800"/>
-            <a:ext cx="2560320" cy="1645920"/>
-          </a:xfrm>
-          <a:prstGeom prst="roundRect">
-            <a:avLst/>
-          </a:prstGeom>
-          <a:solidFill>
-            <a:srgbClr val="111827"/>
-          </a:solidFill>
-          <a:ln w="19050">
-            <a:solidFill>
-              <a:srgbClr val="1F2937"/>
-            </a:solidFill>
-          </a:ln>
-        </p:spPr>
-        <p:style>
-          <a:lnRef idx="1">
-            <a:schemeClr val="accent1"/>
-          </a:lnRef>
-          <a:fillRef idx="3">
-            <a:schemeClr val="accent1"/>
-          </a:fillRef>
-          <a:effectRef idx="2">
-            <a:schemeClr val="accent1"/>
-          </a:effectRef>
-          <a:fontRef idx="minor">
-            <a:schemeClr val="lt1"/>
-          </a:fontRef>
-        </p:style>
-        <p:txBody>
-          <a:bodyPr rtlCol="0" anchor="ctr"/>
-          <a:lstStyle/>
-          <a:p>
-            <a:pPr algn="ctr"/>
-          </a:p>
-        </p:txBody>
-      </p:sp>
-      <p:sp>
-        <p:nvSpPr>
-          <p:cNvPr id="12" name="TextBox 11"/>
-          <p:cNvSpPr txBox="1"/>
-          <p:nvPr/>
-        </p:nvSpPr>
-        <p:spPr>
-          <a:xfrm>
-            <a:off x="9098280" y="1920240"/>
-            <a:ext cx="2286000" cy="1463040"/>
-          </a:xfrm>
-          <a:prstGeom prst="rect">
-            <a:avLst/>
-          </a:prstGeom>
-          <a:noFill/>
-        </p:spPr>
-        <p:txBody>
-          <a:bodyPr wrap="square">
-            <a:spAutoFit/>
-          </a:bodyPr>
-          <a:lstStyle/>
-          <a:p>
-            <a:pPr>
-              <a:defRPr sz="900">
+              <a:t>• Average Revenue per Deal: €5,000</a:t>
+            </a:r>
+          </a:p>
+          <a:p>
+            <a:pPr>
+              <a:spcAft>
+                <a:spcPts val="500"/>
+              </a:spcAft>
+              <a:defRPr sz="1200">
                 <a:solidFill>
                   <a:srgbClr val="94A3B8"/>
                 </a:solidFill>
               </a:defRPr>
             </a:pPr>
             <a:r>
-              <a:t>DECISION OUTPUT</a:t>
-            </a:r>
-          </a:p>
-          <a:p>
-            <a:pPr>
-              <a:defRPr sz="2400" b="1">
-                <a:solidFill>
-                  <a:srgbClr val="10B981"/>
-                </a:solidFill>
-              </a:defRPr>
-            </a:pPr>
-            <a:r>
-              <a:t>APPROVE</a:t>
-            </a:r>
-          </a:p>
-          <a:p>
-            <a:pPr>
-              <a:defRPr sz="1000">
+              <a:t>• Customer Acquisition Cost (CAC): €250</a:t>
+            </a:r>
+          </a:p>
+          <a:p>
+            <a:pPr>
+              <a:spcAft>
+                <a:spcPts val="500"/>
+              </a:spcAft>
+              <a:defRPr sz="1200">
                 <a:solidFill>
                   <a:srgbClr val="94A3B8"/>
                 </a:solidFill>
               </a:defRPr>
             </a:pPr>
             <a:r>
-              <a:t>87% Confidence</a:t>
-            </a:r>
-          </a:p>
-        </p:txBody>
-      </p:sp>
-      <p:sp>
-        <p:nvSpPr>
-          <p:cNvPr id="13" name="Rounded Rectangle 12"/>
-          <p:cNvSpPr/>
-          <p:nvPr/>
-        </p:nvSpPr>
-        <p:spPr>
-          <a:xfrm>
-            <a:off x="731520" y="3749039"/>
-            <a:ext cx="10698480" cy="2468880"/>
-          </a:xfrm>
-          <a:prstGeom prst="roundRect">
-            <a:avLst/>
-          </a:prstGeom>
-          <a:solidFill>
-            <a:srgbClr val="111827"/>
-          </a:solidFill>
-          <a:ln w="19050">
-            <a:solidFill>
-              <a:srgbClr val="1F2937"/>
-            </a:solidFill>
-          </a:ln>
-        </p:spPr>
-        <p:style>
-          <a:lnRef idx="1">
-            <a:schemeClr val="accent1"/>
-          </a:lnRef>
-          <a:fillRef idx="3">
-            <a:schemeClr val="accent1"/>
-          </a:fillRef>
-          <a:effectRef idx="2">
-            <a:schemeClr val="accent1"/>
-          </a:effectRef>
-          <a:fontRef idx="minor">
-            <a:schemeClr val="lt1"/>
-          </a:fontRef>
-        </p:style>
-        <p:txBody>
-          <a:bodyPr rtlCol="0" anchor="ctr"/>
-          <a:lstStyle/>
-          <a:p>
-            <a:pPr algn="ctr"/>
-          </a:p>
-        </p:txBody>
-      </p:sp>
-      <p:sp>
-        <p:nvSpPr>
-          <p:cNvPr id="14" name="TextBox 13"/>
-          <p:cNvSpPr txBox="1"/>
-          <p:nvPr/>
-        </p:nvSpPr>
-        <p:spPr>
-          <a:xfrm>
-            <a:off x="914400" y="3886199"/>
-            <a:ext cx="10332720" cy="457200"/>
-          </a:xfrm>
-          <a:prstGeom prst="rect">
-            <a:avLst/>
-          </a:prstGeom>
-          <a:noFill/>
-        </p:spPr>
-        <p:txBody>
-          <a:bodyPr wrap="none">
-            <a:spAutoFit/>
-          </a:bodyPr>
-          <a:lstStyle/>
-          <a:p>
-            <a:pPr>
-              <a:defRPr sz="1100" b="1">
-                <a:solidFill>
-                  <a:srgbClr val="38BDF8"/>
-                </a:solidFill>
-                <a:latin typeface="Arial"/>
-              </a:defRPr>
-            </a:pPr>
-            <a:r>
-              <a:t>VISUAL AI DECISION TRACE &amp; EVIDENCE GROUNDING</a:t>
-            </a:r>
-          </a:p>
-        </p:txBody>
-      </p:sp>
-      <p:sp>
-        <p:nvSpPr>
-          <p:cNvPr id="15" name="TextBox 14"/>
-          <p:cNvSpPr txBox="1"/>
-          <p:nvPr/>
-        </p:nvSpPr>
-        <p:spPr>
-          <a:xfrm>
-            <a:off x="914400" y="4206240"/>
-            <a:ext cx="10332720" cy="1920240"/>
-          </a:xfrm>
-          <a:prstGeom prst="rect">
-            <a:avLst/>
-          </a:prstGeom>
-          <a:noFill/>
-        </p:spPr>
-        <p:txBody>
-          <a:bodyPr wrap="square">
-            <a:spAutoFit/>
-          </a:bodyPr>
-          <a:lstStyle/>
-          <a:p/>
+              <a:t>• LTV / CAC Ratio: 20x+</a:t>
+            </a:r>
+          </a:p>
           <a:p>
             <a:pPr>
               <a:spcAft>
-                <a:spcPts val="600"/>
+                <a:spcPts val="500"/>
               </a:spcAft>
-              <a:defRPr sz="1200" b="1">
-                <a:solidFill>
-                  <a:srgbClr val="38BDF8"/>
-                </a:solidFill>
-              </a:defRPr>
-            </a:pPr>
-            <a:r>
-              <a:t>1. Ingestion: Request validated -&gt; 2. DuckDB: €14.2M Rev, 18.5% EBITDA -&gt; 3. BdI: Milan 1.82% NPL</a:t>
-            </a:r>
-          </a:p>
-          <a:p>
-            <a:pPr>
-              <a:spcAft>
-                <a:spcPts val="600"/>
-              </a:spcAft>
-              <a:defRPr sz="1200" b="1">
-                <a:solidFill>
-                  <a:srgbClr val="38BDF8"/>
-                </a:solidFill>
-              </a:defRPr>
-            </a:pPr>
-            <a:r>
-              <a:t>4. Lombardia: Sector +4.1% YoY -&gt; 5. RAG: -42% Water Audit Verified -&gt; 6. Deterministic Score -&gt; 7. APPROVE</a:t>
-            </a:r>
-          </a:p>
-          <a:p>
-            <a:pPr>
-              <a:defRPr sz="1100">
+              <a:defRPr sz="1200">
                 <a:solidFill>
                   <a:srgbClr val="94A3B8"/>
                 </a:solidFill>
               </a:defRPr>
             </a:pPr>
             <a:r>
-              <a:t>Grounded Evidence: Banca d'Italia commercial credit database confirms Milanese default rates support standard pricing. EcoTex 2024 ESG audit validates project additionality and eligibility for regional transition capital subsidies.</a:t>
+              <a:t>• Cash-generative from pilot phase without heavy working capital requirements.</a:t>
             </a:r>
           </a:p>
         </p:txBody>
@@ -5824,8 +6269,44 @@
         </p:nvSpPr>
         <p:spPr>
           <a:xfrm>
-            <a:off x="731520" y="457200"/>
-            <a:ext cx="10698480" cy="365760"/>
+            <a:off x="731520" y="411480"/>
+            <a:ext cx="10698480" cy="320040"/>
+          </a:xfrm>
+          <a:prstGeom prst="rect">
+            <a:avLst/>
+          </a:prstGeom>
+          <a:noFill/>
+        </p:spPr>
+        <p:txBody>
+          <a:bodyPr wrap="none">
+            <a:spAutoFit/>
+          </a:bodyPr>
+          <a:lstStyle/>
+          <a:p>
+            <a:pPr>
+              <a:defRPr sz="1100" b="1">
+                <a:solidFill>
+                  <a:srgbClr val="38BDF8"/>
+                </a:solidFill>
+                <a:latin typeface="Arial"/>
+              </a:defRPr>
+            </a:pPr>
+            <a:r>
+              <a:t>IMPLEMENTATION ROADMAP</a:t>
+            </a:r>
+          </a:p>
+        </p:txBody>
+      </p:sp>
+      <p:sp>
+        <p:nvSpPr>
+          <p:cNvPr id="4" name="TextBox 3"/>
+          <p:cNvSpPr txBox="1"/>
+          <p:nvPr/>
+        </p:nvSpPr>
+        <p:spPr>
+          <a:xfrm>
+            <a:off x="731520" y="777240"/>
+            <a:ext cx="10698480" cy="914400"/>
           </a:xfrm>
           <a:prstGeom prst="rect">
             <a:avLst/>
@@ -5839,64 +6320,28 @@
           <a:lstStyle/>
           <a:p>
             <a:pPr>
-              <a:defRPr sz="1000" b="1">
-                <a:solidFill>
-                  <a:srgbClr val="38BDF8"/>
+              <a:defRPr sz="2800" b="1">
+                <a:solidFill>
+                  <a:srgbClr val="FFFFFF"/>
                 </a:solidFill>
                 <a:latin typeface="Arial"/>
               </a:defRPr>
             </a:pPr>
             <a:r>
-              <a:t>INTERACTIVE CAPITAL SENSITIVITY</a:t>
-            </a:r>
-          </a:p>
-        </p:txBody>
-      </p:sp>
-      <p:sp>
-        <p:nvSpPr>
-          <p:cNvPr id="4" name="TextBox 3"/>
-          <p:cNvSpPr txBox="1"/>
-          <p:nvPr/>
-        </p:nvSpPr>
-        <p:spPr>
-          <a:xfrm>
-            <a:off x="731520" y="777240"/>
-            <a:ext cx="10698480" cy="731520"/>
-          </a:xfrm>
-          <a:prstGeom prst="rect">
-            <a:avLst/>
-          </a:prstGeom>
-          <a:noFill/>
-        </p:spPr>
-        <p:txBody>
-          <a:bodyPr wrap="square">
-            <a:spAutoFit/>
-          </a:bodyPr>
-          <a:lstStyle/>
-          <a:p>
-            <a:pPr>
-              <a:defRPr sz="2400" b="1">
-                <a:solidFill>
-                  <a:srgbClr val="FFFFFF"/>
+              <a:t>Execution Plan: From Pilot to Enterprise SME Gateway</a:t>
+            </a:r>
+          </a:p>
+          <a:p>
+            <a:pPr>
+              <a:defRPr sz="1400">
+                <a:solidFill>
+                  <a:srgbClr val="94A3B8"/>
                 </a:solidFill>
                 <a:latin typeface="Arial"/>
               </a:defRPr>
             </a:pPr>
             <a:r>
-              <a:t>What-If Engine: Finding the Capital Tipping Point</a:t>
-            </a:r>
-          </a:p>
-          <a:p>
-            <a:pPr>
-              <a:defRPr sz="1300">
-                <a:solidFill>
-                  <a:srgbClr val="94A3B8"/>
-                </a:solidFill>
-                <a:latin typeface="Arial"/>
-              </a:defRPr>
-            </a:pPr>
-            <a:r>
-              <a:t>When the client asks for €1,000,000, what happens to risk, coverage, and approval?</a:t>
+              <a:t>A focused 3-step operational rollout driving rapid regional traction.</a:t>
             </a:r>
           </a:p>
         </p:txBody>
@@ -5910,7 +6355,7 @@
         <p:spPr>
           <a:xfrm>
             <a:off x="731520" y="2011680"/>
-            <a:ext cx="5120640" cy="4114800"/>
+            <a:ext cx="3383280" cy="4114800"/>
           </a:xfrm>
           <a:prstGeom prst="roundRect">
             <a:avLst/>
@@ -5955,7 +6400,7 @@
         <p:spPr>
           <a:xfrm>
             <a:off x="914400" y="2148840"/>
-            <a:ext cx="4754880" cy="457200"/>
+            <a:ext cx="3017520" cy="411480"/>
           </a:xfrm>
           <a:prstGeom prst="rect">
             <a:avLst/>
@@ -5977,7 +6422,7 @@
               </a:defRPr>
             </a:pPr>
             <a:r>
-              <a:t>BASE CASE FACILITY: €750,000</a:t>
+              <a:t>STEP 1 / 30-DAY PILOT</a:t>
             </a:r>
           </a:p>
         </p:txBody>
@@ -5990,8 +6435,8 @@
         </p:nvSpPr>
         <p:spPr>
           <a:xfrm>
-            <a:off x="914400" y="2651760"/>
-            <a:ext cx="4754880" cy="3291840"/>
+            <a:off x="914400" y="2606040"/>
+            <a:ext cx="3017520" cy="3383280"/>
           </a:xfrm>
           <a:prstGeom prst="rect">
             <a:avLst/>
@@ -6006,1162 +6451,76 @@
           <a:p>
             <a:pPr>
               <a:spcAft>
-                <a:spcPts val="1200"/>
+                <a:spcPts val="1000"/>
               </a:spcAft>
-              <a:defRPr sz="1600" b="1">
-                <a:solidFill>
-                  <a:srgbClr val="10B981"/>
-                </a:solidFill>
-              </a:defRPr>
-            </a:pPr>
-            <a:r>
-              <a:t>Status: APPROVE (87% Confidence)</a:t>
+              <a:defRPr sz="1500" b="1">
+                <a:solidFill>
+                  <a:srgbClr val="FFFFFF"/>
+                </a:solidFill>
+              </a:defRPr>
+            </a:pPr>
+            <a:r>
+              <a:t>Regional Industry Rollout</a:t>
             </a:r>
           </a:p>
           <a:p>
             <a:pPr>
               <a:spcAft>
-                <a:spcPts val="600"/>
+                <a:spcPts val="500"/>
               </a:spcAft>
               <a:defRPr sz="1200">
                 <a:solidFill>
-                  <a:srgbClr val="FFFFFF"/>
-                </a:solidFill>
-              </a:defRPr>
-            </a:pPr>
-            <a:r>
-              <a:t>• Financial Health Score: 82 / 100</a:t>
+                  <a:srgbClr val="94A3B8"/>
+                </a:solidFill>
+              </a:defRPr>
+            </a:pPr>
+            <a:r>
+              <a:t>• Deploy with 5 pilot manufacturing accounting firms in Lombardia.</a:t>
             </a:r>
           </a:p>
           <a:p>
             <a:pPr>
               <a:spcAft>
-                <a:spcPts val="600"/>
+                <a:spcPts val="500"/>
               </a:spcAft>
               <a:defRPr sz="1200">
                 <a:solidFill>
-                  <a:srgbClr val="FFFFFF"/>
-                </a:solidFill>
-              </a:defRPr>
-            </a:pPr>
-            <a:r>
-              <a:t>• Projected DSCR: 1.68x (Resilient debt service buffer)</a:t>
+                  <a:srgbClr val="94A3B8"/>
+                </a:solidFill>
+              </a:defRPr>
+            </a:pPr>
+            <a:r>
+              <a:t>• Benchmark 50 live SME equipment loan dossiers.</a:t>
             </a:r>
           </a:p>
           <a:p>
             <a:pPr>
               <a:spcAft>
-                <a:spcPts val="600"/>
+                <a:spcPts val="500"/>
               </a:spcAft>
               <a:defRPr sz="1200">
                 <a:solidFill>
-                  <a:srgbClr val="FFFFFF"/>
-                </a:solidFill>
-              </a:defRPr>
-            </a:pPr>
-            <a:r>
-              <a:t>• Net Debt / EBITDA: 1.35x (Conservative leverage)</a:t>
+                  <a:srgbClr val="94A3B8"/>
+                </a:solidFill>
+              </a:defRPr>
+            </a:pPr>
+            <a:r>
+              <a:t>• Validate €25M in requested facility volume with partner regional banks.</a:t>
             </a:r>
           </a:p>
           <a:p>
             <a:pPr>
               <a:spcAft>
-                <a:spcPts val="600"/>
+                <a:spcPts val="500"/>
               </a:spcAft>
               <a:defRPr sz="1200">
                 <a:solidFill>
-                  <a:srgbClr val="FFFFFF"/>
-                </a:solidFill>
-              </a:defRPr>
-            </a:pPr>
-            <a:r>
-              <a:t>• Composite Risk: Medium Risk</a:t>
-            </a:r>
-          </a:p>
-          <a:p>
-            <a:pPr>
-              <a:spcAft>
-                <a:spcPts val="600"/>
-              </a:spcAft>
-              <a:defRPr sz="1200">
-                <a:solidFill>
-                  <a:srgbClr val="FFFFFF"/>
-                </a:solidFill>
-              </a:defRPr>
-            </a:pPr>
-            <a:r>
-              <a:t>• Recommendation: Standard commercial loan committee approval</a:t>
-            </a:r>
-          </a:p>
-        </p:txBody>
-      </p:sp>
-      <p:sp>
-        <p:nvSpPr>
-          <p:cNvPr id="8" name="Rounded Rectangle 7"/>
-          <p:cNvSpPr/>
-          <p:nvPr/>
-        </p:nvSpPr>
-        <p:spPr>
-          <a:xfrm>
-            <a:off x="6217920" y="2011680"/>
-            <a:ext cx="5212080" cy="4114800"/>
-          </a:xfrm>
-          <a:prstGeom prst="roundRect">
-            <a:avLst/>
-          </a:prstGeom>
-          <a:solidFill>
-            <a:srgbClr val="111827"/>
-          </a:solidFill>
-          <a:ln w="19050">
-            <a:solidFill>
-              <a:srgbClr val="F59E0B"/>
-            </a:solidFill>
-          </a:ln>
-        </p:spPr>
-        <p:style>
-          <a:lnRef idx="1">
-            <a:schemeClr val="accent1"/>
-          </a:lnRef>
-          <a:fillRef idx="3">
-            <a:schemeClr val="accent1"/>
-          </a:fillRef>
-          <a:effectRef idx="2">
-            <a:schemeClr val="accent1"/>
-          </a:effectRef>
-          <a:fontRef idx="minor">
-            <a:schemeClr val="lt1"/>
-          </a:fontRef>
-        </p:style>
-        <p:txBody>
-          <a:bodyPr rtlCol="0" anchor="ctr"/>
-          <a:lstStyle/>
-          <a:p>
-            <a:pPr algn="ctr"/>
-          </a:p>
-        </p:txBody>
-      </p:sp>
-      <p:sp>
-        <p:nvSpPr>
-          <p:cNvPr id="9" name="TextBox 8"/>
-          <p:cNvSpPr txBox="1"/>
-          <p:nvPr/>
-        </p:nvSpPr>
-        <p:spPr>
-          <a:xfrm>
-            <a:off x="6400800" y="2148840"/>
-            <a:ext cx="4846320" cy="457200"/>
-          </a:xfrm>
-          <a:prstGeom prst="rect">
-            <a:avLst/>
-          </a:prstGeom>
-          <a:noFill/>
-        </p:spPr>
-        <p:txBody>
-          <a:bodyPr wrap="none">
-            <a:spAutoFit/>
-          </a:bodyPr>
-          <a:lstStyle/>
-          <a:p>
-            <a:pPr>
-              <a:defRPr sz="1100" b="1">
-                <a:solidFill>
-                  <a:srgbClr val="38BDF8"/>
-                </a:solidFill>
-                <a:latin typeface="Arial"/>
-              </a:defRPr>
-            </a:pPr>
-            <a:r>
-              <a:t>WHAT-IF SCENARIO: €1,000,000</a:t>
-            </a:r>
-          </a:p>
-        </p:txBody>
-      </p:sp>
-      <p:sp>
-        <p:nvSpPr>
-          <p:cNvPr id="10" name="TextBox 9"/>
-          <p:cNvSpPr txBox="1"/>
-          <p:nvPr/>
-        </p:nvSpPr>
-        <p:spPr>
-          <a:xfrm>
-            <a:off x="6400800" y="2651760"/>
-            <a:ext cx="4846320" cy="3291840"/>
-          </a:xfrm>
-          <a:prstGeom prst="rect">
-            <a:avLst/>
-          </a:prstGeom>
-          <a:noFill/>
-        </p:spPr>
-        <p:txBody>
-          <a:bodyPr wrap="square">
-            <a:spAutoFit/>
-          </a:bodyPr>
-          <a:lstStyle/>
-          <a:p>
-            <a:pPr>
-              <a:spcAft>
-                <a:spcPts val="1200"/>
-              </a:spcAft>
-              <a:defRPr sz="1600" b="1">
-                <a:solidFill>
-                  <a:srgbClr val="F59E0B"/>
-                </a:solidFill>
-              </a:defRPr>
-            </a:pPr>
-            <a:r>
-              <a:t>Status: REVIEW (Underwriter Alert)</a:t>
-            </a:r>
-          </a:p>
-          <a:p>
-            <a:pPr>
-              <a:spcAft>
-                <a:spcPts val="600"/>
-              </a:spcAft>
-              <a:defRPr sz="1200">
-                <a:solidFill>
-                  <a:srgbClr val="FFFFFF"/>
-                </a:solidFill>
-              </a:defRPr>
-            </a:pPr>
-            <a:r>
-              <a:t>• Financial Health Score: 74 / 100 (Drop of 8 points)</a:t>
-            </a:r>
-          </a:p>
-          <a:p>
-            <a:pPr>
-              <a:spcAft>
-                <a:spcPts val="600"/>
-              </a:spcAft>
-              <a:defRPr sz="1200">
-                <a:solidFill>
-                  <a:srgbClr val="FFFFFF"/>
-                </a:solidFill>
-              </a:defRPr>
-            </a:pPr>
-            <a:r>
-              <a:t>• Projected DSCR: 1.28x (Breaches safe covenant threshold)</a:t>
-            </a:r>
-          </a:p>
-          <a:p>
-            <a:pPr>
-              <a:spcAft>
-                <a:spcPts val="600"/>
-              </a:spcAft>
-              <a:defRPr sz="1200">
-                <a:solidFill>
-                  <a:srgbClr val="FFFFFF"/>
-                </a:solidFill>
-              </a:defRPr>
-            </a:pPr>
-            <a:r>
-              <a:t>• Net Debt / EBITDA: 1.95x (Elevated debt burden)</a:t>
-            </a:r>
-          </a:p>
-          <a:p>
-            <a:pPr>
-              <a:spcAft>
-                <a:spcPts val="600"/>
-              </a:spcAft>
-              <a:defRPr sz="1200">
-                <a:solidFill>
-                  <a:srgbClr val="FFFFFF"/>
-                </a:solidFill>
-              </a:defRPr>
-            </a:pPr>
-            <a:r>
-              <a:t>• Composite Risk: High Risk Tier</a:t>
-            </a:r>
-          </a:p>
-          <a:p>
-            <a:pPr>
-              <a:spcAft>
-                <a:spcPts val="600"/>
-              </a:spcAft>
-              <a:defRPr sz="1200">
-                <a:solidFill>
-                  <a:srgbClr val="FFFFFF"/>
-                </a:solidFill>
-              </a:defRPr>
-            </a:pPr>
-            <a:r>
-              <a:t>• Recommendation: Escalation required; requires covenant guarantees</a:t>
-            </a:r>
-          </a:p>
-        </p:txBody>
-      </p:sp>
-    </p:spTree>
-  </p:cSld>
-  <p:clrMapOvr>
-    <a:masterClrMapping/>
-  </p:clrMapOvr>
-</p:sld>
-</file>
-
-<file path=ppt/slides/slide7.xml><?xml version="1.0" encoding="utf-8"?>
-<p:sld xmlns:a="http://schemas.openxmlformats.org/drawingml/2006/main" xmlns:p="http://schemas.openxmlformats.org/presentationml/2006/main" xmlns:r="http://schemas.openxmlformats.org/officeDocument/2006/relationships">
-  <p:cSld>
-    <p:spTree>
-      <p:nvGrpSpPr>
-        <p:cNvPr id="1" name=""/>
-        <p:cNvGrpSpPr/>
-        <p:nvPr/>
-      </p:nvGrpSpPr>
-      <p:grpSpPr/>
-      <p:sp>
-        <p:nvSpPr>
-          <p:cNvPr id="2" name="Rectangle 1"/>
-          <p:cNvSpPr/>
-          <p:nvPr/>
-        </p:nvSpPr>
-        <p:spPr>
-          <a:xfrm>
-            <a:off x="0" y="0"/>
-            <a:ext cx="12191695" cy="6858000"/>
-          </a:xfrm>
-          <a:prstGeom prst="rect">
-            <a:avLst/>
-          </a:prstGeom>
-          <a:solidFill>
-            <a:srgbClr val="0B0F19"/>
-          </a:solidFill>
-          <a:ln>
-            <a:solidFill>
-              <a:srgbClr val="0B0F19"/>
-            </a:solidFill>
-          </a:ln>
-        </p:spPr>
-        <p:style>
-          <a:lnRef idx="1">
-            <a:schemeClr val="accent1"/>
-          </a:lnRef>
-          <a:fillRef idx="3">
-            <a:schemeClr val="accent1"/>
-          </a:fillRef>
-          <a:effectRef idx="2">
-            <a:schemeClr val="accent1"/>
-          </a:effectRef>
-          <a:fontRef idx="minor">
-            <a:schemeClr val="lt1"/>
-          </a:fontRef>
-        </p:style>
-        <p:txBody>
-          <a:bodyPr rtlCol="0" anchor="ctr"/>
-          <a:lstStyle/>
-          <a:p>
-            <a:pPr algn="ctr"/>
-          </a:p>
-        </p:txBody>
-      </p:sp>
-      <p:sp>
-        <p:nvSpPr>
-          <p:cNvPr id="3" name="TextBox 2"/>
-          <p:cNvSpPr txBox="1"/>
-          <p:nvPr/>
-        </p:nvSpPr>
-        <p:spPr>
-          <a:xfrm>
-            <a:off x="731520" y="457200"/>
-            <a:ext cx="10698480" cy="365760"/>
-          </a:xfrm>
-          <a:prstGeom prst="rect">
-            <a:avLst/>
-          </a:prstGeom>
-          <a:noFill/>
-        </p:spPr>
-        <p:txBody>
-          <a:bodyPr wrap="square">
-            <a:spAutoFit/>
-          </a:bodyPr>
-          <a:lstStyle/>
-          <a:p>
-            <a:pPr>
-              <a:defRPr sz="1000" b="1">
-                <a:solidFill>
-                  <a:srgbClr val="38BDF8"/>
-                </a:solidFill>
-                <a:latin typeface="Arial"/>
-              </a:defRPr>
-            </a:pPr>
-            <a:r>
-              <a:t>COMMERCIAL IMPACT</a:t>
-            </a:r>
-          </a:p>
-        </p:txBody>
-      </p:sp>
-      <p:sp>
-        <p:nvSpPr>
-          <p:cNvPr id="4" name="TextBox 3"/>
-          <p:cNvSpPr txBox="1"/>
-          <p:nvPr/>
-        </p:nvSpPr>
-        <p:spPr>
-          <a:xfrm>
-            <a:off x="731520" y="777240"/>
-            <a:ext cx="10698480" cy="731520"/>
-          </a:xfrm>
-          <a:prstGeom prst="rect">
-            <a:avLst/>
-          </a:prstGeom>
-          <a:noFill/>
-        </p:spPr>
-        <p:txBody>
-          <a:bodyPr wrap="square">
-            <a:spAutoFit/>
-          </a:bodyPr>
-          <a:lstStyle/>
-          <a:p>
-            <a:pPr>
-              <a:defRPr sz="2400" b="1">
-                <a:solidFill>
-                  <a:srgbClr val="FFFFFF"/>
-                </a:solidFill>
-                <a:latin typeface="Arial"/>
-              </a:defRPr>
-            </a:pPr>
-            <a:r>
-              <a:t>From 14 Days to 14 Seconds: Strategic Value</a:t>
-            </a:r>
-          </a:p>
-          <a:p>
-            <a:pPr>
-              <a:defRPr sz="1300">
-                <a:solidFill>
                   <a:srgbClr val="94A3B8"/>
                 </a:solidFill>
-                <a:latin typeface="Arial"/>
-              </a:defRPr>
-            </a:pPr>
-            <a:r>
-              <a:t>Quantifiable efficiency, compliance assurance, and higher lending margins.</a:t>
-            </a:r>
-          </a:p>
-        </p:txBody>
-      </p:sp>
-      <p:sp>
-        <p:nvSpPr>
-          <p:cNvPr id="5" name="Rounded Rectangle 4"/>
-          <p:cNvSpPr/>
-          <p:nvPr/>
-        </p:nvSpPr>
-        <p:spPr>
-          <a:xfrm>
-            <a:off x="731520" y="2011680"/>
-            <a:ext cx="3383280" cy="4114800"/>
-          </a:xfrm>
-          <a:prstGeom prst="roundRect">
-            <a:avLst/>
-          </a:prstGeom>
-          <a:solidFill>
-            <a:srgbClr val="111827"/>
-          </a:solidFill>
-          <a:ln w="19050">
-            <a:solidFill>
-              <a:srgbClr val="2563EB"/>
-            </a:solidFill>
-          </a:ln>
-        </p:spPr>
-        <p:style>
-          <a:lnRef idx="1">
-            <a:schemeClr val="accent1"/>
-          </a:lnRef>
-          <a:fillRef idx="3">
-            <a:schemeClr val="accent1"/>
-          </a:fillRef>
-          <a:effectRef idx="2">
-            <a:schemeClr val="accent1"/>
-          </a:effectRef>
-          <a:fontRef idx="minor">
-            <a:schemeClr val="lt1"/>
-          </a:fontRef>
-        </p:style>
-        <p:txBody>
-          <a:bodyPr rtlCol="0" anchor="ctr"/>
-          <a:lstStyle/>
-          <a:p>
-            <a:pPr algn="ctr"/>
-          </a:p>
-        </p:txBody>
-      </p:sp>
-      <p:sp>
-        <p:nvSpPr>
-          <p:cNvPr id="6" name="TextBox 5"/>
-          <p:cNvSpPr txBox="1"/>
-          <p:nvPr/>
-        </p:nvSpPr>
-        <p:spPr>
-          <a:xfrm>
-            <a:off x="914400" y="2148840"/>
-            <a:ext cx="3017520" cy="457200"/>
-          </a:xfrm>
-          <a:prstGeom prst="rect">
-            <a:avLst/>
-          </a:prstGeom>
-          <a:noFill/>
-        </p:spPr>
-        <p:txBody>
-          <a:bodyPr wrap="none">
-            <a:spAutoFit/>
-          </a:bodyPr>
-          <a:lstStyle/>
-          <a:p>
-            <a:pPr>
-              <a:defRPr sz="1100" b="1">
-                <a:solidFill>
-                  <a:srgbClr val="38BDF8"/>
-                </a:solidFill>
-                <a:latin typeface="Arial"/>
-              </a:defRPr>
-            </a:pPr>
-            <a:r>
-              <a:t>EFFICIENCY</a:t>
-            </a:r>
-          </a:p>
-        </p:txBody>
-      </p:sp>
-      <p:sp>
-        <p:nvSpPr>
-          <p:cNvPr id="7" name="TextBox 6"/>
-          <p:cNvSpPr txBox="1"/>
-          <p:nvPr/>
-        </p:nvSpPr>
-        <p:spPr>
-          <a:xfrm>
-            <a:off x="960120" y="2651760"/>
-            <a:ext cx="2926080" cy="3200400"/>
-          </a:xfrm>
-          <a:prstGeom prst="rect">
-            <a:avLst/>
-          </a:prstGeom>
-          <a:noFill/>
-        </p:spPr>
-        <p:txBody>
-          <a:bodyPr wrap="square">
-            <a:spAutoFit/>
-          </a:bodyPr>
-          <a:lstStyle/>
-          <a:p>
-            <a:pPr>
-              <a:spcAft>
-                <a:spcPts val="1400"/>
-              </a:spcAft>
-              <a:defRPr sz="1600" b="1">
-                <a:solidFill>
-                  <a:srgbClr val="FFFFFF"/>
-                </a:solidFill>
-              </a:defRPr>
-            </a:pPr>
-            <a:r>
-              <a:t>-85% Underwriting Time</a:t>
-            </a:r>
-          </a:p>
-          <a:p>
-            <a:pPr>
-              <a:lnSpc>
-                <a:spcPct val="130000"/>
-              </a:lnSpc>
-              <a:defRPr sz="1300">
-                <a:solidFill>
-                  <a:srgbClr val="94A3B8"/>
-                </a:solidFill>
-              </a:defRPr>
-            </a:pPr>
-            <a:r>
-              <a:t>Cuts preliminary credit assessment from 14 business days to under 15 seconds, allowing RMs to handle 4x deal volume without adding analyst headcount.</a:t>
-            </a:r>
-          </a:p>
-        </p:txBody>
-      </p:sp>
-      <p:sp>
-        <p:nvSpPr>
-          <p:cNvPr id="8" name="Rounded Rectangle 7"/>
-          <p:cNvSpPr/>
-          <p:nvPr/>
-        </p:nvSpPr>
-        <p:spPr>
-          <a:xfrm>
-            <a:off x="4389120" y="2011680"/>
-            <a:ext cx="3383280" cy="4114800"/>
-          </a:xfrm>
-          <a:prstGeom prst="roundRect">
-            <a:avLst/>
-          </a:prstGeom>
-          <a:solidFill>
-            <a:srgbClr val="111827"/>
-          </a:solidFill>
-          <a:ln w="19050">
-            <a:solidFill>
-              <a:srgbClr val="2563EB"/>
-            </a:solidFill>
-          </a:ln>
-        </p:spPr>
-        <p:style>
-          <a:lnRef idx="1">
-            <a:schemeClr val="accent1"/>
-          </a:lnRef>
-          <a:fillRef idx="3">
-            <a:schemeClr val="accent1"/>
-          </a:fillRef>
-          <a:effectRef idx="2">
-            <a:schemeClr val="accent1"/>
-          </a:effectRef>
-          <a:fontRef idx="minor">
-            <a:schemeClr val="lt1"/>
-          </a:fontRef>
-        </p:style>
-        <p:txBody>
-          <a:bodyPr rtlCol="0" anchor="ctr"/>
-          <a:lstStyle/>
-          <a:p>
-            <a:pPr algn="ctr"/>
-          </a:p>
-        </p:txBody>
-      </p:sp>
-      <p:sp>
-        <p:nvSpPr>
-          <p:cNvPr id="9" name="TextBox 8"/>
-          <p:cNvSpPr txBox="1"/>
-          <p:nvPr/>
-        </p:nvSpPr>
-        <p:spPr>
-          <a:xfrm>
-            <a:off x="4572000" y="2148840"/>
-            <a:ext cx="3017520" cy="457200"/>
-          </a:xfrm>
-          <a:prstGeom prst="rect">
-            <a:avLst/>
-          </a:prstGeom>
-          <a:noFill/>
-        </p:spPr>
-        <p:txBody>
-          <a:bodyPr wrap="none">
-            <a:spAutoFit/>
-          </a:bodyPr>
-          <a:lstStyle/>
-          <a:p>
-            <a:pPr>
-              <a:defRPr sz="1100" b="1">
-                <a:solidFill>
-                  <a:srgbClr val="38BDF8"/>
-                </a:solidFill>
-                <a:latin typeface="Arial"/>
-              </a:defRPr>
-            </a:pPr>
-            <a:r>
-              <a:t>COMPLIANCE</a:t>
-            </a:r>
-          </a:p>
-        </p:txBody>
-      </p:sp>
-      <p:sp>
-        <p:nvSpPr>
-          <p:cNvPr id="10" name="TextBox 9"/>
-          <p:cNvSpPr txBox="1"/>
-          <p:nvPr/>
-        </p:nvSpPr>
-        <p:spPr>
-          <a:xfrm>
-            <a:off x="4617720" y="2651760"/>
-            <a:ext cx="2926080" cy="3200400"/>
-          </a:xfrm>
-          <a:prstGeom prst="rect">
-            <a:avLst/>
-          </a:prstGeom>
-          <a:noFill/>
-        </p:spPr>
-        <p:txBody>
-          <a:bodyPr wrap="square">
-            <a:spAutoFit/>
-          </a:bodyPr>
-          <a:lstStyle/>
-          <a:p>
-            <a:pPr>
-              <a:spcAft>
-                <a:spcPts val="1400"/>
-              </a:spcAft>
-              <a:defRPr sz="1600" b="1">
-                <a:solidFill>
-                  <a:srgbClr val="FFFFFF"/>
-                </a:solidFill>
-              </a:defRPr>
-            </a:pPr>
-            <a:r>
-              <a:t>100% Audit Traceability</a:t>
-            </a:r>
-          </a:p>
-          <a:p>
-            <a:pPr>
-              <a:lnSpc>
-                <a:spcPct val="130000"/>
-              </a:lnSpc>
-              <a:defRPr sz="1300">
-                <a:solidFill>
-                  <a:srgbClr val="94A3B8"/>
-                </a:solidFill>
-              </a:defRPr>
-            </a:pPr>
-            <a:r>
-              <a:t>Fully compliant with EBA loan origination guidelines and EU CSRD reporting. Every claim is attributed to exact public and audited sources.</a:t>
-            </a:r>
-          </a:p>
-        </p:txBody>
-      </p:sp>
-      <p:sp>
-        <p:nvSpPr>
-          <p:cNvPr id="11" name="Rounded Rectangle 10"/>
-          <p:cNvSpPr/>
-          <p:nvPr/>
-        </p:nvSpPr>
-        <p:spPr>
-          <a:xfrm>
-            <a:off x="8046720" y="2011680"/>
-            <a:ext cx="3383280" cy="4114800"/>
-          </a:xfrm>
-          <a:prstGeom prst="roundRect">
-            <a:avLst/>
-          </a:prstGeom>
-          <a:solidFill>
-            <a:srgbClr val="111827"/>
-          </a:solidFill>
-          <a:ln w="19050">
-            <a:solidFill>
-              <a:srgbClr val="2563EB"/>
-            </a:solidFill>
-          </a:ln>
-        </p:spPr>
-        <p:style>
-          <a:lnRef idx="1">
-            <a:schemeClr val="accent1"/>
-          </a:lnRef>
-          <a:fillRef idx="3">
-            <a:schemeClr val="accent1"/>
-          </a:fillRef>
-          <a:effectRef idx="2">
-            <a:schemeClr val="accent1"/>
-          </a:effectRef>
-          <a:fontRef idx="minor">
-            <a:schemeClr val="lt1"/>
-          </a:fontRef>
-        </p:style>
-        <p:txBody>
-          <a:bodyPr rtlCol="0" anchor="ctr"/>
-          <a:lstStyle/>
-          <a:p>
-            <a:pPr algn="ctr"/>
-          </a:p>
-        </p:txBody>
-      </p:sp>
-      <p:sp>
-        <p:nvSpPr>
-          <p:cNvPr id="12" name="TextBox 11"/>
-          <p:cNvSpPr txBox="1"/>
-          <p:nvPr/>
-        </p:nvSpPr>
-        <p:spPr>
-          <a:xfrm>
-            <a:off x="8229600" y="2148840"/>
-            <a:ext cx="3017520" cy="457200"/>
-          </a:xfrm>
-          <a:prstGeom prst="rect">
-            <a:avLst/>
-          </a:prstGeom>
-          <a:noFill/>
-        </p:spPr>
-        <p:txBody>
-          <a:bodyPr wrap="none">
-            <a:spAutoFit/>
-          </a:bodyPr>
-          <a:lstStyle/>
-          <a:p>
-            <a:pPr>
-              <a:defRPr sz="1100" b="1">
-                <a:solidFill>
-                  <a:srgbClr val="38BDF8"/>
-                </a:solidFill>
-                <a:latin typeface="Arial"/>
-              </a:defRPr>
-            </a:pPr>
-            <a:r>
-              <a:t>RISK CONTROL</a:t>
-            </a:r>
-          </a:p>
-        </p:txBody>
-      </p:sp>
-      <p:sp>
-        <p:nvSpPr>
-          <p:cNvPr id="13" name="TextBox 12"/>
-          <p:cNvSpPr txBox="1"/>
-          <p:nvPr/>
-        </p:nvSpPr>
-        <p:spPr>
-          <a:xfrm>
-            <a:off x="8275320" y="2651760"/>
-            <a:ext cx="2926080" cy="3200400"/>
-          </a:xfrm>
-          <a:prstGeom prst="rect">
-            <a:avLst/>
-          </a:prstGeom>
-          <a:noFill/>
-        </p:spPr>
-        <p:txBody>
-          <a:bodyPr wrap="square">
-            <a:spAutoFit/>
-          </a:bodyPr>
-          <a:lstStyle/>
-          <a:p>
-            <a:pPr>
-              <a:spcAft>
-                <a:spcPts val="1400"/>
-              </a:spcAft>
-              <a:defRPr sz="1600" b="1">
-                <a:solidFill>
-                  <a:srgbClr val="FFFFFF"/>
-                </a:solidFill>
-              </a:defRPr>
-            </a:pPr>
-            <a:r>
-              <a:t>Zero Calculator Hallucination</a:t>
-            </a:r>
-          </a:p>
-          <a:p>
-            <a:pPr>
-              <a:lnSpc>
-                <a:spcPct val="130000"/>
-              </a:lnSpc>
-              <a:defRPr sz="1300">
-                <a:solidFill>
-                  <a:srgbClr val="94A3B8"/>
-                </a:solidFill>
-              </a:defRPr>
-            </a:pPr>
-            <a:r>
-              <a:t>Eliminates generative AI liability. Credit committees gain deterministic mathematical safety combined with natural language intelligence.</a:t>
-            </a:r>
-          </a:p>
-        </p:txBody>
-      </p:sp>
-    </p:spTree>
-  </p:cSld>
-  <p:clrMapOvr>
-    <a:masterClrMapping/>
-  </p:clrMapOvr>
-</p:sld>
-</file>
-
-<file path=ppt/slides/slide8.xml><?xml version="1.0" encoding="utf-8"?>
-<p:sld xmlns:a="http://schemas.openxmlformats.org/drawingml/2006/main" xmlns:p="http://schemas.openxmlformats.org/presentationml/2006/main" xmlns:r="http://schemas.openxmlformats.org/officeDocument/2006/relationships">
-  <p:cSld>
-    <p:spTree>
-      <p:nvGrpSpPr>
-        <p:cNvPr id="1" name=""/>
-        <p:cNvGrpSpPr/>
-        <p:nvPr/>
-      </p:nvGrpSpPr>
-      <p:grpSpPr/>
-      <p:sp>
-        <p:nvSpPr>
-          <p:cNvPr id="2" name="Rectangle 1"/>
-          <p:cNvSpPr/>
-          <p:nvPr/>
-        </p:nvSpPr>
-        <p:spPr>
-          <a:xfrm>
-            <a:off x="0" y="0"/>
-            <a:ext cx="12191695" cy="6858000"/>
-          </a:xfrm>
-          <a:prstGeom prst="rect">
-            <a:avLst/>
-          </a:prstGeom>
-          <a:solidFill>
-            <a:srgbClr val="0B0F19"/>
-          </a:solidFill>
-          <a:ln>
-            <a:solidFill>
-              <a:srgbClr val="0B0F19"/>
-            </a:solidFill>
-          </a:ln>
-        </p:spPr>
-        <p:style>
-          <a:lnRef idx="1">
-            <a:schemeClr val="accent1"/>
-          </a:lnRef>
-          <a:fillRef idx="3">
-            <a:schemeClr val="accent1"/>
-          </a:fillRef>
-          <a:effectRef idx="2">
-            <a:schemeClr val="accent1"/>
-          </a:effectRef>
-          <a:fontRef idx="minor">
-            <a:schemeClr val="lt1"/>
-          </a:fontRef>
-        </p:style>
-        <p:txBody>
-          <a:bodyPr rtlCol="0" anchor="ctr"/>
-          <a:lstStyle/>
-          <a:p>
-            <a:pPr algn="ctr"/>
-          </a:p>
-        </p:txBody>
-      </p:sp>
-      <p:sp>
-        <p:nvSpPr>
-          <p:cNvPr id="3" name="TextBox 2"/>
-          <p:cNvSpPr txBox="1"/>
-          <p:nvPr/>
-        </p:nvSpPr>
-        <p:spPr>
-          <a:xfrm>
-            <a:off x="731520" y="457200"/>
-            <a:ext cx="10698480" cy="365760"/>
-          </a:xfrm>
-          <a:prstGeom prst="rect">
-            <a:avLst/>
-          </a:prstGeom>
-          <a:noFill/>
-        </p:spPr>
-        <p:txBody>
-          <a:bodyPr wrap="square">
-            <a:spAutoFit/>
-          </a:bodyPr>
-          <a:lstStyle/>
-          <a:p>
-            <a:pPr>
-              <a:defRPr sz="1000" b="1">
-                <a:solidFill>
-                  <a:srgbClr val="38BDF8"/>
-                </a:solidFill>
-                <a:latin typeface="Arial"/>
-              </a:defRPr>
-            </a:pPr>
-            <a:r>
-              <a:t>PLATFORM VISION</a:t>
-            </a:r>
-          </a:p>
-        </p:txBody>
-      </p:sp>
-      <p:sp>
-        <p:nvSpPr>
-          <p:cNvPr id="4" name="TextBox 3"/>
-          <p:cNvSpPr txBox="1"/>
-          <p:nvPr/>
-        </p:nvSpPr>
-        <p:spPr>
-          <a:xfrm>
-            <a:off x="731520" y="777240"/>
-            <a:ext cx="10698480" cy="731520"/>
-          </a:xfrm>
-          <a:prstGeom prst="rect">
-            <a:avLst/>
-          </a:prstGeom>
-          <a:noFill/>
-        </p:spPr>
-        <p:txBody>
-          <a:bodyPr wrap="square">
-            <a:spAutoFit/>
-          </a:bodyPr>
-          <a:lstStyle/>
-          <a:p>
-            <a:pPr>
-              <a:defRPr sz="2400" b="1">
-                <a:solidFill>
-                  <a:srgbClr val="FFFFFF"/>
-                </a:solidFill>
-                <a:latin typeface="Arial"/>
-              </a:defRPr>
-            </a:pPr>
-            <a:r>
-              <a:t>The Horizon: Autonomous Portfolio Intelligence</a:t>
-            </a:r>
-          </a:p>
-          <a:p>
-            <a:pPr>
-              <a:defRPr sz="1300">
-                <a:solidFill>
-                  <a:srgbClr val="94A3B8"/>
-                </a:solidFill>
-                <a:latin typeface="Arial"/>
-              </a:defRPr>
-            </a:pPr>
-            <a:r>
-              <a:t>SME credit is our proving ground. The same engine expands across the bank.</a:t>
-            </a:r>
-          </a:p>
-        </p:txBody>
-      </p:sp>
-      <p:sp>
-        <p:nvSpPr>
-          <p:cNvPr id="5" name="Rounded Rectangle 4"/>
-          <p:cNvSpPr/>
-          <p:nvPr/>
-        </p:nvSpPr>
-        <p:spPr>
-          <a:xfrm>
-            <a:off x="731520" y="2011680"/>
-            <a:ext cx="3383280" cy="4114800"/>
-          </a:xfrm>
-          <a:prstGeom prst="roundRect">
-            <a:avLst/>
-          </a:prstGeom>
-          <a:solidFill>
-            <a:srgbClr val="111827"/>
-          </a:solidFill>
-          <a:ln w="19050">
-            <a:solidFill>
-              <a:srgbClr val="38BDF8"/>
-            </a:solidFill>
-          </a:ln>
-        </p:spPr>
-        <p:style>
-          <a:lnRef idx="1">
-            <a:schemeClr val="accent1"/>
-          </a:lnRef>
-          <a:fillRef idx="3">
-            <a:schemeClr val="accent1"/>
-          </a:fillRef>
-          <a:effectRef idx="2">
-            <a:schemeClr val="accent1"/>
-          </a:effectRef>
-          <a:fontRef idx="minor">
-            <a:schemeClr val="lt1"/>
-          </a:fontRef>
-        </p:style>
-        <p:txBody>
-          <a:bodyPr rtlCol="0" anchor="ctr"/>
-          <a:lstStyle/>
-          <a:p>
-            <a:pPr algn="ctr"/>
-          </a:p>
-        </p:txBody>
-      </p:sp>
-      <p:sp>
-        <p:nvSpPr>
-          <p:cNvPr id="6" name="TextBox 5"/>
-          <p:cNvSpPr txBox="1"/>
-          <p:nvPr/>
-        </p:nvSpPr>
-        <p:spPr>
-          <a:xfrm>
-            <a:off x="914400" y="2148840"/>
-            <a:ext cx="3017520" cy="457200"/>
-          </a:xfrm>
-          <a:prstGeom prst="rect">
-            <a:avLst/>
-          </a:prstGeom>
-          <a:noFill/>
-        </p:spPr>
-        <p:txBody>
-          <a:bodyPr wrap="none">
-            <a:spAutoFit/>
-          </a:bodyPr>
-          <a:lstStyle/>
-          <a:p>
-            <a:pPr>
-              <a:defRPr sz="1100" b="1">
-                <a:solidFill>
-                  <a:srgbClr val="38BDF8"/>
-                </a:solidFill>
-                <a:latin typeface="Arial"/>
-              </a:defRPr>
-            </a:pPr>
-            <a:r>
-              <a:t>PHASE 1: PRESENT SLICE</a:t>
-            </a:r>
-          </a:p>
-        </p:txBody>
-      </p:sp>
-      <p:sp>
-        <p:nvSpPr>
-          <p:cNvPr id="7" name="TextBox 6"/>
-          <p:cNvSpPr txBox="1"/>
-          <p:nvPr/>
-        </p:nvSpPr>
-        <p:spPr>
-          <a:xfrm>
-            <a:off x="960120" y="2651760"/>
-            <a:ext cx="2926080" cy="3200400"/>
-          </a:xfrm>
-          <a:prstGeom prst="rect">
-            <a:avLst/>
-          </a:prstGeom>
-          <a:noFill/>
-        </p:spPr>
-        <p:txBody>
-          <a:bodyPr wrap="square">
-            <a:spAutoFit/>
-          </a:bodyPr>
-          <a:lstStyle/>
-          <a:p>
-            <a:pPr>
-              <a:spcAft>
-                <a:spcPts val="1200"/>
-              </a:spcAft>
-              <a:defRPr sz="1500" b="1">
-                <a:solidFill>
-                  <a:srgbClr val="FFFFFF"/>
-                </a:solidFill>
-              </a:defRPr>
-            </a:pPr>
-            <a:r>
-              <a:t>SME Credit Engine</a:t>
-            </a:r>
-          </a:p>
-          <a:p>
-            <a:pPr>
-              <a:spcAft>
-                <a:spcPts val="600"/>
-              </a:spcAft>
-              <a:defRPr sz="1200">
-                <a:solidFill>
-                  <a:srgbClr val="94A3B8"/>
-                </a:solidFill>
-              </a:defRPr>
-            </a:pPr>
-            <a:r>
-              <a:t>• Single loan proposal analysis</a:t>
-            </a:r>
-          </a:p>
-          <a:p>
-            <a:pPr>
-              <a:spcAft>
-                <a:spcPts val="600"/>
-              </a:spcAft>
-              <a:defRPr sz="1200">
-                <a:solidFill>
-                  <a:srgbClr val="94A3B8"/>
-                </a:solidFill>
-              </a:defRPr>
-            </a:pPr>
-            <a:r>
-              <a:t>• DuckDB structured layer</a:t>
-            </a:r>
-          </a:p>
-          <a:p>
-            <a:pPr>
-              <a:spcAft>
-                <a:spcPts val="600"/>
-              </a:spcAft>
-              <a:defRPr sz="1200">
-                <a:solidFill>
-                  <a:srgbClr val="94A3B8"/>
-                </a:solidFill>
-              </a:defRPr>
-            </a:pPr>
-            <a:r>
-              <a:t>• Banca d'Italia &amp; Lombardia data</a:t>
-            </a:r>
-          </a:p>
-          <a:p>
-            <a:pPr>
-              <a:spcAft>
-                <a:spcPts val="600"/>
-              </a:spcAft>
-              <a:defRPr sz="1200">
-                <a:solidFill>
-                  <a:srgbClr val="94A3B8"/>
-                </a:solidFill>
-              </a:defRPr>
-            </a:pPr>
-            <a:r>
-              <a:t>• Deterministic scoring &amp; What-If</a:t>
+              </a:defRPr>
+            </a:pPr>
+            <a:r>
+              <a:t>• Metric: 100% dossier approval rate.</a:t>
             </a:r>
           </a:p>
         </p:txBody>
@@ -7220,7 +6579,7 @@
         <p:spPr>
           <a:xfrm>
             <a:off x="4572000" y="2148840"/>
-            <a:ext cx="3017520" cy="457200"/>
+            <a:ext cx="3017520" cy="411480"/>
           </a:xfrm>
           <a:prstGeom prst="rect">
             <a:avLst/>
@@ -7242,7 +6601,7 @@
               </a:defRPr>
             </a:pPr>
             <a:r>
-              <a:t>PHASE 2: COMMERCIAL SCALE</a:t>
+              <a:t>STEP 2 / 90-DAY SCALE</a:t>
             </a:r>
           </a:p>
         </p:txBody>
@@ -7255,8 +6614,8 @@
         </p:nvSpPr>
         <p:spPr>
           <a:xfrm>
-            <a:off x="4617720" y="2651760"/>
-            <a:ext cx="2926080" cy="3200400"/>
+            <a:off x="4572000" y="2606040"/>
+            <a:ext cx="3017520" cy="3383280"/>
           </a:xfrm>
           <a:prstGeom prst="rect">
             <a:avLst/>
@@ -7271,7 +6630,7 @@
           <a:p>
             <a:pPr>
               <a:spcAft>
-                <a:spcPts val="1200"/>
+                <a:spcPts val="1000"/>
               </a:spcAft>
               <a:defRPr sz="1500" b="1">
                 <a:solidFill>
@@ -7280,13 +6639,13 @@
               </a:defRPr>
             </a:pPr>
             <a:r>
-              <a:t>Portfolio Stress Testing</a:t>
+              <a:t>Multi-Lender Marketplace</a:t>
             </a:r>
           </a:p>
           <a:p>
             <a:pPr>
               <a:spcAft>
-                <a:spcPts val="600"/>
+                <a:spcPts val="500"/>
               </a:spcAft>
               <a:defRPr sz="1200">
                 <a:solidFill>
@@ -7295,13 +6654,13 @@
               </a:defRPr>
             </a:pPr>
             <a:r>
-              <a:t>• Automated covenant monitoring</a:t>
+              <a:t>• Expand distribution via regional industrial associations (Confindustria).</a:t>
             </a:r>
           </a:p>
           <a:p>
             <a:pPr>
               <a:spcAft>
-                <a:spcPts val="600"/>
+                <a:spcPts val="500"/>
               </a:spcAft>
               <a:defRPr sz="1200">
                 <a:solidFill>
@@ -7310,13 +6669,13 @@
               </a:defRPr>
             </a:pPr>
             <a:r>
-              <a:t>• Sector-wide macro shock simulation</a:t>
+              <a:t>• Onboard 15 digital credit funds &amp; commercial banks to compete for deals.</a:t>
             </a:r>
           </a:p>
           <a:p>
             <a:pPr>
               <a:spcAft>
-                <a:spcPts val="600"/>
+                <a:spcPts val="500"/>
               </a:spcAft>
               <a:defRPr sz="1200">
                 <a:solidFill>
@@ -7325,13 +6684,13 @@
               </a:defRPr>
             </a:pPr>
             <a:r>
-              <a:t>• Continuous early-warning signals</a:t>
+              <a:t>• Launch automated regional green grant matching module.</a:t>
             </a:r>
           </a:p>
           <a:p>
             <a:pPr>
               <a:spcAft>
-                <a:spcPts val="600"/>
+                <a:spcPts val="500"/>
               </a:spcAft>
               <a:defRPr sz="1200">
                 <a:solidFill>
@@ -7340,7 +6699,7 @@
               </a:defRPr>
             </a:pPr>
             <a:r>
-              <a:t>• Climate transition risk audit</a:t>
+              <a:t>• Target: €100M originated facility volume.</a:t>
             </a:r>
           </a:p>
         </p:txBody>
@@ -7399,7 +6758,7 @@
         <p:spPr>
           <a:xfrm>
             <a:off x="8229600" y="2148840"/>
-            <a:ext cx="3017520" cy="457200"/>
+            <a:ext cx="3017520" cy="411480"/>
           </a:xfrm>
           <a:prstGeom prst="rect">
             <a:avLst/>
@@ -7421,7 +6780,7 @@
               </a:defRPr>
             </a:pPr>
             <a:r>
-              <a:t>PHASE 3: WEALTH &amp; ADVISORY</a:t>
+              <a:t>STEP 3 / 12-MONTH OS</a:t>
             </a:r>
           </a:p>
         </p:txBody>
@@ -7434,8 +6793,8 @@
         </p:nvSpPr>
         <p:spPr>
           <a:xfrm>
-            <a:off x="8275320" y="2651760"/>
-            <a:ext cx="2926080" cy="3200400"/>
+            <a:off x="8229600" y="2606040"/>
+            <a:ext cx="3017520" cy="3383280"/>
           </a:xfrm>
           <a:prstGeom prst="rect">
             <a:avLst/>
@@ -7450,7 +6809,7 @@
           <a:p>
             <a:pPr>
               <a:spcAft>
-                <a:spcPts val="1200"/>
+                <a:spcPts val="1000"/>
               </a:spcAft>
               <a:defRPr sz="1500" b="1">
                 <a:solidFill>
@@ -7459,13 +6818,13 @@
               </a:defRPr>
             </a:pPr>
             <a:r>
-              <a:t>Enterprise Intelligence</a:t>
+              <a:t>The Corporate Capital Gateway</a:t>
             </a:r>
           </a:p>
           <a:p>
             <a:pPr>
               <a:spcAft>
-                <a:spcPts val="600"/>
+                <a:spcPts val="500"/>
               </a:spcAft>
               <a:defRPr sz="1200">
                 <a:solidFill>
@@ -7474,13 +6833,13 @@
               </a:defRPr>
             </a:pPr>
             <a:r>
-              <a:t>• Private wealth advisory co-pilot</a:t>
+              <a:t>• Expand from debt origination to continuous SME treasury intelligence.</a:t>
             </a:r>
           </a:p>
           <a:p>
             <a:pPr>
               <a:spcAft>
-                <a:spcPts val="600"/>
+                <a:spcPts val="500"/>
               </a:spcAft>
               <a:defRPr sz="1200">
                 <a:solidFill>
@@ -7489,13 +6848,13 @@
               </a:defRPr>
             </a:pPr>
             <a:r>
-              <a:t>• Multi-asset liquidity optimization</a:t>
+              <a:t>• Automated covenant monitoring and working capital optimization.</a:t>
             </a:r>
           </a:p>
           <a:p>
             <a:pPr>
               <a:spcAft>
-                <a:spcPts val="600"/>
+                <a:spcPts val="500"/>
               </a:spcAft>
               <a:defRPr sz="1200">
                 <a:solidFill>
@@ -7504,13 +6863,13 @@
               </a:defRPr>
             </a:pPr>
             <a:r>
-              <a:t>• Cross-border regulatory intelligence</a:t>
+              <a:t>• The definitive financial operating system for European SME capital.</a:t>
             </a:r>
           </a:p>
           <a:p>
             <a:pPr>
               <a:spcAft>
-                <a:spcPts val="600"/>
+                <a:spcPts val="500"/>
               </a:spcAft>
               <a:defRPr sz="1200">
                 <a:solidFill>
@@ -7519,7 +6878,7 @@
               </a:defRPr>
             </a:pPr>
             <a:r>
-              <a:t>• Autonomous corporate deal structuring</a:t>
+              <a:t>• Pan-European expansion into DACH and France.</a:t>
             </a:r>
           </a:p>
         </p:txBody>

</xml_diff>